<commit_message>
fix: align release radar and snapshot deployment
</commit_message>
<xml_diff>
--- a/docs/demo/pokestock-demo.pptx
+++ b/docs/demo/pokestock-demo.pptx
@@ -2,22 +2,22 @@
 <file path=ppt/presentation.xml><?xml version="1.0" encoding="utf-8"?>
 <p:presentation xmlns:p="http://schemas.openxmlformats.org/presentationml/2006/main">
   <p:sldMasterIdLst>
-    <p:sldMasterId xmlns:r="http://schemas.openxmlformats.org/officeDocument/2006/relationships" id="2147483648" r:id="R12698e6414cd44dd"/>
+    <p:sldMasterId xmlns:r="http://schemas.openxmlformats.org/officeDocument/2006/relationships" id="2147483648" r:id="Rb55a8b8b08d649d2"/>
   </p:sldMasterIdLst>
   <p:notesMasterIdLst>
-    <p:notesMasterId xmlns:r="http://schemas.openxmlformats.org/officeDocument/2006/relationships" r:id="Rb07008598d264aa9"/>
+    <p:notesMasterId xmlns:r="http://schemas.openxmlformats.org/officeDocument/2006/relationships" r:id="R80149f5528e6481f"/>
   </p:notesMasterIdLst>
   <p:sldIdLst>
-    <p:sldId xmlns:r="http://schemas.openxmlformats.org/officeDocument/2006/relationships" id="256" r:id="R967055e3e3064dc8"/>
-    <p:sldId xmlns:r="http://schemas.openxmlformats.org/officeDocument/2006/relationships" id="257" r:id="Ra2fe82fc8ed94a1d"/>
-    <p:sldId xmlns:r="http://schemas.openxmlformats.org/officeDocument/2006/relationships" id="258" r:id="R8017e602c8094829"/>
-    <p:sldId xmlns:r="http://schemas.openxmlformats.org/officeDocument/2006/relationships" id="259" r:id="Raca9b9ccd3924293"/>
-    <p:sldId xmlns:r="http://schemas.openxmlformats.org/officeDocument/2006/relationships" id="260" r:id="R60e8f37637b744c6"/>
-    <p:sldId xmlns:r="http://schemas.openxmlformats.org/officeDocument/2006/relationships" id="261" r:id="R740a17de91c64292"/>
-    <p:sldId xmlns:r="http://schemas.openxmlformats.org/officeDocument/2006/relationships" id="262" r:id="Rdbb0cd4f86f84997"/>
-    <p:sldId xmlns:r="http://schemas.openxmlformats.org/officeDocument/2006/relationships" id="263" r:id="R37096e8595bb45d7"/>
-    <p:sldId xmlns:r="http://schemas.openxmlformats.org/officeDocument/2006/relationships" id="264" r:id="R1b772e7eed4e4578"/>
-    <p:sldId xmlns:r="http://schemas.openxmlformats.org/officeDocument/2006/relationships" id="265" r:id="R8aa57c17e2f94f09"/>
+    <p:sldId xmlns:r="http://schemas.openxmlformats.org/officeDocument/2006/relationships" id="256" r:id="Rb2b29670402d484e"/>
+    <p:sldId xmlns:r="http://schemas.openxmlformats.org/officeDocument/2006/relationships" id="257" r:id="Rae071ecffec24da4"/>
+    <p:sldId xmlns:r="http://schemas.openxmlformats.org/officeDocument/2006/relationships" id="258" r:id="Re55af276ff354d0a"/>
+    <p:sldId xmlns:r="http://schemas.openxmlformats.org/officeDocument/2006/relationships" id="259" r:id="R31b67138a1d040f9"/>
+    <p:sldId xmlns:r="http://schemas.openxmlformats.org/officeDocument/2006/relationships" id="260" r:id="R150098dd881d447b"/>
+    <p:sldId xmlns:r="http://schemas.openxmlformats.org/officeDocument/2006/relationships" id="261" r:id="R0ae0efb510874d7b"/>
+    <p:sldId xmlns:r="http://schemas.openxmlformats.org/officeDocument/2006/relationships" id="262" r:id="R848b21c68fee48c9"/>
+    <p:sldId xmlns:r="http://schemas.openxmlformats.org/officeDocument/2006/relationships" id="263" r:id="Ra222a3cd80a44e6c"/>
+    <p:sldId xmlns:r="http://schemas.openxmlformats.org/officeDocument/2006/relationships" id="264" r:id="Rcc2b7e84738746d4"/>
+    <p:sldId xmlns:r="http://schemas.openxmlformats.org/officeDocument/2006/relationships" id="265" r:id="R4d4744834c5b4b49"/>
   </p:sldIdLst>
   <p:sldSz cx="12192000" cy="6858000"/>
   <p:notesSz cx="6858000" cy="9144000"/>
@@ -1204,7 +1204,7 @@
   </p:cSld>
   <p:clrMap bg1="lt1" tx1="dk1" bg2="lt2" tx2="dk2" accent1="accent1" accent2="accent2" accent3="accent3" accent4="accent4" accent5="accent5" accent6="accent6" hlink="hlink" folHlink="folHlink"/>
   <p:sldLayoutIdLst>
-    <p:sldLayoutId xmlns:r="http://schemas.openxmlformats.org/officeDocument/2006/relationships" id="2147483649" r:id="Rcec44031c16e4c4e"/>
+    <p:sldLayoutId xmlns:r="http://schemas.openxmlformats.org/officeDocument/2006/relationships" id="2147483649" r:id="Rcabc122208854cec"/>
   </p:sldLayoutIdLst>
   <p:txStyles>
     <p:titleStyle>
@@ -1759,7 +1759,7 @@
           <p:nvPr/>
         </p:nvPicPr>
         <p:blipFill>
-          <a:blip xmlns:r="http://schemas.openxmlformats.org/officeDocument/2006/relationships" xmlns:a="http://schemas.openxmlformats.org/drawingml/2006/main" r:embed="R1dbb9e7650574e78"/>
+          <a:blip xmlns:r="http://schemas.openxmlformats.org/officeDocument/2006/relationships" xmlns:a="http://schemas.openxmlformats.org/drawingml/2006/main" r:embed="Rc1a9e79b13d04ddb"/>
           <a:srcRect xmlns:a="http://schemas.openxmlformats.org/drawingml/2006/main" l="0" t="0" r="0" b="0"/>
           <a:stretch xmlns:a="http://schemas.openxmlformats.org/drawingml/2006/main">
             <a:fillRect l="0" t="0" r="0" b="0"/>
@@ -1782,7 +1782,7 @@
           <p:cNvPr id="2" name="">
             <a:extLst xmlns:a="http://schemas.openxmlformats.org/drawingml/2006/main">
               <a:ext uri="{FF2B5EF4-FFF2-40B4-BE49-F238E27FC236}">
-                <a16:creationId xmlns:a16="http://schemas.microsoft.com/office/drawing/2014/main" id="{8D581639-5E95-4363-8E7A-BF423FEBCF82}"/>
+                <a16:creationId xmlns:a16="http://schemas.microsoft.com/office/drawing/2014/main" id="{5820B36C-2198-4EA5-BF06-0652E33EB577}"/>
               </a:ext>
             </a:extLst>
           </p:cNvPr>
@@ -1815,7 +1815,7 @@
           <p:cNvPr id="3" name="">
             <a:extLst xmlns:a="http://schemas.openxmlformats.org/drawingml/2006/main">
               <a:ext uri="{FF2B5EF4-FFF2-40B4-BE49-F238E27FC236}">
-                <a16:creationId xmlns:a16="http://schemas.microsoft.com/office/drawing/2014/main" id="{EF2A0A49-0201-4276-AC9E-22EC0643F504}"/>
+                <a16:creationId xmlns:a16="http://schemas.microsoft.com/office/drawing/2014/main" id="{0917FE94-E40F-4F59-A9A5-467FB56F6F4E}"/>
               </a:ext>
             </a:extLst>
           </p:cNvPr>
@@ -1865,7 +1865,7 @@
           <p:cNvPr id="4" name="">
             <a:extLst xmlns:a="http://schemas.openxmlformats.org/drawingml/2006/main">
               <a:ext uri="{FF2B5EF4-FFF2-40B4-BE49-F238E27FC236}">
-                <a16:creationId xmlns:a16="http://schemas.microsoft.com/office/drawing/2014/main" id="{18CFA3D8-78C6-4B19-98F6-C1A3B41162DB}"/>
+                <a16:creationId xmlns:a16="http://schemas.microsoft.com/office/drawing/2014/main" id="{8686009F-30E4-40B3-84AA-03B4F77CC713}"/>
               </a:ext>
             </a:extLst>
           </p:cNvPr>
@@ -1913,7 +1913,7 @@
     </p:spTree>
     <p:extLst>
       <p:ext uri="{BB962C8B-B14F-4D97-AF65-F5344CB8AC3E}">
-        <p14:creationId xmlns:p14="http://schemas.microsoft.com/office/powerpoint/2010/main" val="1154910508"/>
+        <p14:creationId xmlns:p14="http://schemas.microsoft.com/office/powerpoint/2010/main" val="1788278612"/>
       </p:ext>
     </p:extLst>
   </p:cSld>
@@ -1944,7 +1944,7 @@
           <p:cNvPr id="12" name="">
             <a:extLst xmlns:a="http://schemas.openxmlformats.org/drawingml/2006/main">
               <a:ext uri="{FF2B5EF4-FFF2-40B4-BE49-F238E27FC236}">
-                <a16:creationId xmlns:a16="http://schemas.microsoft.com/office/drawing/2014/main" id="{95362B4D-03C5-4C6C-B855-09A107DDF0DB}"/>
+                <a16:creationId xmlns:a16="http://schemas.microsoft.com/office/drawing/2014/main" id="{7CE8582D-6C33-462C-904D-BB298388810E}"/>
               </a:ext>
             </a:extLst>
           </p:cNvPr>
@@ -1977,7 +1977,7 @@
           <p:cNvPr id="2" name="">
             <a:extLst xmlns:a="http://schemas.openxmlformats.org/drawingml/2006/main">
               <a:ext uri="{FF2B5EF4-FFF2-40B4-BE49-F238E27FC236}">
-                <a16:creationId xmlns:a16="http://schemas.microsoft.com/office/drawing/2014/main" id="{22702BC7-DB83-4835-A83B-2812F7BB016C}"/>
+                <a16:creationId xmlns:a16="http://schemas.microsoft.com/office/drawing/2014/main" id="{66FDF767-5E8D-4164-A3F3-030F3EAD8F60}"/>
               </a:ext>
             </a:extLst>
           </p:cNvPr>
@@ -2010,7 +2010,7 @@
           <p:cNvPr id="3" name="">
             <a:extLst xmlns:a="http://schemas.openxmlformats.org/drawingml/2006/main">
               <a:ext uri="{FF2B5EF4-FFF2-40B4-BE49-F238E27FC236}">
-                <a16:creationId xmlns:a16="http://schemas.microsoft.com/office/drawing/2014/main" id="{193F7FF8-32FE-47BE-A162-BCC625EC5B2B}"/>
+                <a16:creationId xmlns:a16="http://schemas.microsoft.com/office/drawing/2014/main" id="{08F6CBAC-F974-48FD-9477-9B9D476485CE}"/>
               </a:ext>
             </a:extLst>
           </p:cNvPr>
@@ -2043,7 +2043,7 @@
           <p:cNvPr id="4" name="">
             <a:extLst xmlns:a="http://schemas.openxmlformats.org/drawingml/2006/main">
               <a:ext uri="{FF2B5EF4-FFF2-40B4-BE49-F238E27FC236}">
-                <a16:creationId xmlns:a16="http://schemas.microsoft.com/office/drawing/2014/main" id="{11833659-55FE-4385-8C4A-BE706C8326A4}"/>
+                <a16:creationId xmlns:a16="http://schemas.microsoft.com/office/drawing/2014/main" id="{1C776D8B-CB06-4BDC-A992-87A94EE51A13}"/>
               </a:ext>
             </a:extLst>
           </p:cNvPr>
@@ -2093,7 +2093,7 @@
           <p:cNvPr id="5" name="">
             <a:extLst xmlns:a="http://schemas.openxmlformats.org/drawingml/2006/main">
               <a:ext uri="{FF2B5EF4-FFF2-40B4-BE49-F238E27FC236}">
-                <a16:creationId xmlns:a16="http://schemas.microsoft.com/office/drawing/2014/main" id="{FD65700C-91A5-4BDF-9A40-8C2CF7FBC8E0}"/>
+                <a16:creationId xmlns:a16="http://schemas.microsoft.com/office/drawing/2014/main" id="{06DAC14A-BF1F-441A-874D-2F449B813084}"/>
               </a:ext>
             </a:extLst>
           </p:cNvPr>
@@ -2143,7 +2143,7 @@
           <p:cNvPr id="6" name="">
             <a:extLst xmlns:a="http://schemas.openxmlformats.org/drawingml/2006/main">
               <a:ext uri="{FF2B5EF4-FFF2-40B4-BE49-F238E27FC236}">
-                <a16:creationId xmlns:a16="http://schemas.microsoft.com/office/drawing/2014/main" id="{F6909FED-2230-4166-8433-576461874413}"/>
+                <a16:creationId xmlns:a16="http://schemas.microsoft.com/office/drawing/2014/main" id="{094E1372-4937-4115-A1E1-69DE075C3A85}"/>
               </a:ext>
             </a:extLst>
           </p:cNvPr>
@@ -2176,7 +2176,7 @@
           <p:cNvPr id="7" name="">
             <a:extLst xmlns:a="http://schemas.openxmlformats.org/drawingml/2006/main">
               <a:ext uri="{FF2B5EF4-FFF2-40B4-BE49-F238E27FC236}">
-                <a16:creationId xmlns:a16="http://schemas.microsoft.com/office/drawing/2014/main" id="{F2A50A19-8EDF-41D9-9F4A-0020747109D7}"/>
+                <a16:creationId xmlns:a16="http://schemas.microsoft.com/office/drawing/2014/main" id="{1A8E8EB0-7187-453C-B302-205CD715C8A8}"/>
               </a:ext>
             </a:extLst>
           </p:cNvPr>
@@ -2226,7 +2226,7 @@
           <p:cNvPr id="8" name="">
             <a:extLst xmlns:a="http://schemas.openxmlformats.org/drawingml/2006/main">
               <a:ext uri="{FF2B5EF4-FFF2-40B4-BE49-F238E27FC236}">
-                <a16:creationId xmlns:a16="http://schemas.microsoft.com/office/drawing/2014/main" id="{160F15F9-F8E1-43CC-802F-C1BE5D9D8B3B}"/>
+                <a16:creationId xmlns:a16="http://schemas.microsoft.com/office/drawing/2014/main" id="{206542E3-8591-4A22-91E6-775724ED173A}"/>
               </a:ext>
             </a:extLst>
           </p:cNvPr>
@@ -2276,7 +2276,7 @@
           <p:cNvPr id="9" name="">
             <a:extLst xmlns:a="http://schemas.openxmlformats.org/drawingml/2006/main">
               <a:ext uri="{FF2B5EF4-FFF2-40B4-BE49-F238E27FC236}">
-                <a16:creationId xmlns:a16="http://schemas.microsoft.com/office/drawing/2014/main" id="{7A8770D7-FEEC-48DD-8523-B11BF1C92C2F}"/>
+                <a16:creationId xmlns:a16="http://schemas.microsoft.com/office/drawing/2014/main" id="{BF27976B-102D-463A-BA08-28F51BB82E02}"/>
               </a:ext>
             </a:extLst>
           </p:cNvPr>
@@ -2309,7 +2309,7 @@
           <p:cNvPr id="10" name="">
             <a:extLst xmlns:a="http://schemas.openxmlformats.org/drawingml/2006/main">
               <a:ext uri="{FF2B5EF4-FFF2-40B4-BE49-F238E27FC236}">
-                <a16:creationId xmlns:a16="http://schemas.microsoft.com/office/drawing/2014/main" id="{C2436D4A-3DE8-40B3-9AB8-333DB7ED6405}"/>
+                <a16:creationId xmlns:a16="http://schemas.microsoft.com/office/drawing/2014/main" id="{57CCC06E-5EDC-4DB9-ABD3-E42FDB733DC3}"/>
               </a:ext>
             </a:extLst>
           </p:cNvPr>
@@ -2342,7 +2342,7 @@
           <p:cNvPr id="11" name="">
             <a:extLst xmlns:a="http://schemas.openxmlformats.org/drawingml/2006/main">
               <a:ext uri="{FF2B5EF4-FFF2-40B4-BE49-F238E27FC236}">
-                <a16:creationId xmlns:a16="http://schemas.microsoft.com/office/drawing/2014/main" id="{E7572D1E-8940-4329-9CAF-256DDD534906}"/>
+                <a16:creationId xmlns:a16="http://schemas.microsoft.com/office/drawing/2014/main" id="{2CC13B3D-21D7-4208-BB19-E0EA604F9E76}"/>
               </a:ext>
             </a:extLst>
           </p:cNvPr>
@@ -2390,7 +2390,7 @@
     </p:spTree>
     <p:extLst>
       <p:ext uri="{BB962C8B-B14F-4D97-AF65-F5344CB8AC3E}">
-        <p14:creationId xmlns:p14="http://schemas.microsoft.com/office/powerpoint/2010/main" val="1173203626"/>
+        <p14:creationId xmlns:p14="http://schemas.microsoft.com/office/powerpoint/2010/main" val="824328059"/>
       </p:ext>
     </p:extLst>
   </p:cSld>
@@ -2421,7 +2421,7 @@
           <p:cNvPr id="13" name="">
             <a:extLst xmlns:a="http://schemas.openxmlformats.org/drawingml/2006/main">
               <a:ext uri="{FF2B5EF4-FFF2-40B4-BE49-F238E27FC236}">
-                <a16:creationId xmlns:a16="http://schemas.microsoft.com/office/drawing/2014/main" id="{89E35F25-D11B-4DFC-A37D-61DCA7BD3483}"/>
+                <a16:creationId xmlns:a16="http://schemas.microsoft.com/office/drawing/2014/main" id="{4B7F6300-457D-4A2D-B0A8-98412DECD533}"/>
               </a:ext>
             </a:extLst>
           </p:cNvPr>
@@ -2471,7 +2471,7 @@
           <p:cNvPr id="2" name="">
             <a:extLst xmlns:a="http://schemas.openxmlformats.org/drawingml/2006/main">
               <a:ext uri="{FF2B5EF4-FFF2-40B4-BE49-F238E27FC236}">
-                <a16:creationId xmlns:a16="http://schemas.microsoft.com/office/drawing/2014/main" id="{EDA3F654-BAA1-45A1-A2CC-A75206466F68}"/>
+                <a16:creationId xmlns:a16="http://schemas.microsoft.com/office/drawing/2014/main" id="{78F634EA-8CE2-46FC-98E3-39025D20F044}"/>
               </a:ext>
             </a:extLst>
           </p:cNvPr>
@@ -2521,7 +2521,7 @@
           <p:cNvPr id="3" name="">
             <a:extLst xmlns:a="http://schemas.openxmlformats.org/drawingml/2006/main">
               <a:ext uri="{FF2B5EF4-FFF2-40B4-BE49-F238E27FC236}">
-                <a16:creationId xmlns:a16="http://schemas.microsoft.com/office/drawing/2014/main" id="{D305CAAF-17B0-489D-BBAD-989E459B7EF3}"/>
+                <a16:creationId xmlns:a16="http://schemas.microsoft.com/office/drawing/2014/main" id="{BEE68A75-BCBB-4EC8-AF66-11ECDD7056CE}"/>
               </a:ext>
             </a:extLst>
           </p:cNvPr>
@@ -2571,7 +2571,7 @@
           <p:cNvPr id="4" name="">
             <a:extLst xmlns:a="http://schemas.openxmlformats.org/drawingml/2006/main">
               <a:ext uri="{FF2B5EF4-FFF2-40B4-BE49-F238E27FC236}">
-                <a16:creationId xmlns:a16="http://schemas.microsoft.com/office/drawing/2014/main" id="{1A656755-4FD1-4A07-BDB5-07188E1AF917}"/>
+                <a16:creationId xmlns:a16="http://schemas.microsoft.com/office/drawing/2014/main" id="{09E11E46-F8BC-49F8-82C0-96C32B53A95B}"/>
               </a:ext>
             </a:extLst>
           </p:cNvPr>
@@ -2621,7 +2621,7 @@
           <p:cNvPr id="5" name="">
             <a:extLst xmlns:a="http://schemas.openxmlformats.org/drawingml/2006/main">
               <a:ext uri="{FF2B5EF4-FFF2-40B4-BE49-F238E27FC236}">
-                <a16:creationId xmlns:a16="http://schemas.microsoft.com/office/drawing/2014/main" id="{E059CC23-F7CE-47C4-9052-11995E535A64}"/>
+                <a16:creationId xmlns:a16="http://schemas.microsoft.com/office/drawing/2014/main" id="{2285EA9E-1300-4868-9879-C19B9374CA36}"/>
               </a:ext>
             </a:extLst>
           </p:cNvPr>
@@ -2671,7 +2671,7 @@
           <p:cNvPr id="6" name="">
             <a:extLst xmlns:a="http://schemas.openxmlformats.org/drawingml/2006/main">
               <a:ext uri="{FF2B5EF4-FFF2-40B4-BE49-F238E27FC236}">
-                <a16:creationId xmlns:a16="http://schemas.microsoft.com/office/drawing/2014/main" id="{6D01D4C4-E3F1-4C6A-83C2-39432E7E14FC}"/>
+                <a16:creationId xmlns:a16="http://schemas.microsoft.com/office/drawing/2014/main" id="{9EEFB486-C4FE-415F-814D-B4E5338E6D43}"/>
               </a:ext>
             </a:extLst>
           </p:cNvPr>
@@ -2721,7 +2721,7 @@
           <p:cNvPr id="7" name="">
             <a:extLst xmlns:a="http://schemas.openxmlformats.org/drawingml/2006/main">
               <a:ext uri="{FF2B5EF4-FFF2-40B4-BE49-F238E27FC236}">
-                <a16:creationId xmlns:a16="http://schemas.microsoft.com/office/drawing/2014/main" id="{687B68DB-4D71-4527-975F-662E9DAB3AC4}"/>
+                <a16:creationId xmlns:a16="http://schemas.microsoft.com/office/drawing/2014/main" id="{AB5C2A8F-A6E9-46B3-AAB3-9993FF80DC0A}"/>
               </a:ext>
             </a:extLst>
           </p:cNvPr>
@@ -2771,7 +2771,7 @@
           <p:cNvPr id="8" name="">
             <a:extLst xmlns:a="http://schemas.openxmlformats.org/drawingml/2006/main">
               <a:ext uri="{FF2B5EF4-FFF2-40B4-BE49-F238E27FC236}">
-                <a16:creationId xmlns:a16="http://schemas.microsoft.com/office/drawing/2014/main" id="{7304F8CE-AAA1-4034-BCBC-769690DB95D4}"/>
+                <a16:creationId xmlns:a16="http://schemas.microsoft.com/office/drawing/2014/main" id="{C82815A0-A00F-45C8-A6F9-2C1910404224}"/>
               </a:ext>
             </a:extLst>
           </p:cNvPr>
@@ -2825,7 +2825,7 @@
           <p:nvPr/>
         </p:nvPicPr>
         <p:blipFill>
-          <a:blip xmlns:r="http://schemas.openxmlformats.org/officeDocument/2006/relationships" xmlns:a="http://schemas.openxmlformats.org/drawingml/2006/main" r:embed="R34a9ed6a9f0f4a9c"/>
+          <a:blip xmlns:r="http://schemas.openxmlformats.org/officeDocument/2006/relationships" xmlns:a="http://schemas.openxmlformats.org/drawingml/2006/main" r:embed="R5e07f8c1a62a4a05"/>
           <a:srcRect xmlns:a="http://schemas.openxmlformats.org/drawingml/2006/main" l="0" t="42511" r="0" b="42511"/>
           <a:stretch xmlns:a="http://schemas.openxmlformats.org/drawingml/2006/main">
             <a:fillRect l="0" t="0" r="0" b="0"/>
@@ -2848,7 +2848,7 @@
           <p:cNvPr id="10" name="">
             <a:extLst xmlns:a="http://schemas.openxmlformats.org/drawingml/2006/main">
               <a:ext uri="{FF2B5EF4-FFF2-40B4-BE49-F238E27FC236}">
-                <a16:creationId xmlns:a16="http://schemas.microsoft.com/office/drawing/2014/main" id="{EEAA2EEB-0718-4AF3-814F-4A908C8C3BC9}"/>
+                <a16:creationId xmlns:a16="http://schemas.microsoft.com/office/drawing/2014/main" id="{746D57B9-2E51-4F45-BD57-186160049D59}"/>
               </a:ext>
             </a:extLst>
           </p:cNvPr>
@@ -2881,7 +2881,7 @@
           <p:cNvPr id="11" name="">
             <a:extLst xmlns:a="http://schemas.openxmlformats.org/drawingml/2006/main">
               <a:ext uri="{FF2B5EF4-FFF2-40B4-BE49-F238E27FC236}">
-                <a16:creationId xmlns:a16="http://schemas.microsoft.com/office/drawing/2014/main" id="{FA3F0BAC-F514-472C-AC82-4E744B2EDC0C}"/>
+                <a16:creationId xmlns:a16="http://schemas.microsoft.com/office/drawing/2014/main" id="{CA2A15F3-A04A-413B-BB60-EA1AED781487}"/>
               </a:ext>
             </a:extLst>
           </p:cNvPr>
@@ -2914,7 +2914,7 @@
           <p:cNvPr id="12" name="">
             <a:extLst xmlns:a="http://schemas.openxmlformats.org/drawingml/2006/main">
               <a:ext uri="{FF2B5EF4-FFF2-40B4-BE49-F238E27FC236}">
-                <a16:creationId xmlns:a16="http://schemas.microsoft.com/office/drawing/2014/main" id="{E6399DF8-51A6-4597-9A6D-183FD9D171EB}"/>
+                <a16:creationId xmlns:a16="http://schemas.microsoft.com/office/drawing/2014/main" id="{9662A930-6469-439D-B868-A88B451F1EF3}"/>
               </a:ext>
             </a:extLst>
           </p:cNvPr>
@@ -2962,7 +2962,7 @@
     </p:spTree>
     <p:extLst>
       <p:ext uri="{BB962C8B-B14F-4D97-AF65-F5344CB8AC3E}">
-        <p14:creationId xmlns:p14="http://schemas.microsoft.com/office/powerpoint/2010/main" val="1287186459"/>
+        <p14:creationId xmlns:p14="http://schemas.microsoft.com/office/powerpoint/2010/main" val="69078942"/>
       </p:ext>
     </p:extLst>
   </p:cSld>
@@ -2993,7 +2993,7 @@
           <p:cNvPr id="26" name="">
             <a:extLst xmlns:a="http://schemas.openxmlformats.org/drawingml/2006/main">
               <a:ext uri="{FF2B5EF4-FFF2-40B4-BE49-F238E27FC236}">
-                <a16:creationId xmlns:a16="http://schemas.microsoft.com/office/drawing/2014/main" id="{196827D3-061F-42D6-ADF4-27429B522800}"/>
+                <a16:creationId xmlns:a16="http://schemas.microsoft.com/office/drawing/2014/main" id="{001D1178-60F3-49D3-9A14-259D49DF807E}"/>
               </a:ext>
             </a:extLst>
           </p:cNvPr>
@@ -3043,7 +3043,7 @@
           <p:cNvPr id="2" name="">
             <a:extLst xmlns:a="http://schemas.openxmlformats.org/drawingml/2006/main">
               <a:ext uri="{FF2B5EF4-FFF2-40B4-BE49-F238E27FC236}">
-                <a16:creationId xmlns:a16="http://schemas.microsoft.com/office/drawing/2014/main" id="{FE3CE16C-0CC1-4B0C-83B6-2CCF3F335A26}"/>
+                <a16:creationId xmlns:a16="http://schemas.microsoft.com/office/drawing/2014/main" id="{90DC59A7-367D-4353-B518-70A3C1AE16AC}"/>
               </a:ext>
             </a:extLst>
           </p:cNvPr>
@@ -3093,7 +3093,7 @@
           <p:cNvPr id="3" name="">
             <a:extLst xmlns:a="http://schemas.openxmlformats.org/drawingml/2006/main">
               <a:ext uri="{FF2B5EF4-FFF2-40B4-BE49-F238E27FC236}">
-                <a16:creationId xmlns:a16="http://schemas.microsoft.com/office/drawing/2014/main" id="{E6D3FC3A-4F93-443C-BC17-83479C1042AF}"/>
+                <a16:creationId xmlns:a16="http://schemas.microsoft.com/office/drawing/2014/main" id="{7E86DEA2-C6A8-44D4-940E-8A7A362D7508}"/>
               </a:ext>
             </a:extLst>
           </p:cNvPr>
@@ -3126,7 +3126,7 @@
           <p:cNvPr id="4" name="">
             <a:extLst xmlns:a="http://schemas.openxmlformats.org/drawingml/2006/main">
               <a:ext uri="{FF2B5EF4-FFF2-40B4-BE49-F238E27FC236}">
-                <a16:creationId xmlns:a16="http://schemas.microsoft.com/office/drawing/2014/main" id="{B423A4CF-CF4F-47F8-94C5-40C82826A19D}"/>
+                <a16:creationId xmlns:a16="http://schemas.microsoft.com/office/drawing/2014/main" id="{A2F677FF-6A85-4BFD-A82E-235C97ECC0C1}"/>
               </a:ext>
             </a:extLst>
           </p:cNvPr>
@@ -3159,7 +3159,7 @@
           <p:cNvPr id="5" name="">
             <a:extLst xmlns:a="http://schemas.openxmlformats.org/drawingml/2006/main">
               <a:ext uri="{FF2B5EF4-FFF2-40B4-BE49-F238E27FC236}">
-                <a16:creationId xmlns:a16="http://schemas.microsoft.com/office/drawing/2014/main" id="{C85A2ADC-618F-4D4B-90E5-B820786F10DE}"/>
+                <a16:creationId xmlns:a16="http://schemas.microsoft.com/office/drawing/2014/main" id="{3DAB8023-D10C-4303-B585-54E5D0C54904}"/>
               </a:ext>
             </a:extLst>
           </p:cNvPr>
@@ -3192,7 +3192,7 @@
           <p:cNvPr id="6" name="">
             <a:extLst xmlns:a="http://schemas.openxmlformats.org/drawingml/2006/main">
               <a:ext uri="{FF2B5EF4-FFF2-40B4-BE49-F238E27FC236}">
-                <a16:creationId xmlns:a16="http://schemas.microsoft.com/office/drawing/2014/main" id="{AB4BE118-5CBB-4C01-A62A-5D67CEC2C3B7}"/>
+                <a16:creationId xmlns:a16="http://schemas.microsoft.com/office/drawing/2014/main" id="{E63A19AE-15E8-4B4F-AE83-FA42F89089DB}"/>
               </a:ext>
             </a:extLst>
           </p:cNvPr>
@@ -3225,7 +3225,7 @@
           <p:cNvPr id="7" name="">
             <a:extLst xmlns:a="http://schemas.openxmlformats.org/drawingml/2006/main">
               <a:ext uri="{FF2B5EF4-FFF2-40B4-BE49-F238E27FC236}">
-                <a16:creationId xmlns:a16="http://schemas.microsoft.com/office/drawing/2014/main" id="{554FD60E-D402-4421-A040-5E44556D1D0F}"/>
+                <a16:creationId xmlns:a16="http://schemas.microsoft.com/office/drawing/2014/main" id="{5D02AEE4-F62B-42F4-A649-5863491D2777}"/>
               </a:ext>
             </a:extLst>
           </p:cNvPr>
@@ -3260,7 +3260,7 @@
           <p:cNvPr id="8" name="">
             <a:extLst xmlns:a="http://schemas.openxmlformats.org/drawingml/2006/main">
               <a:ext uri="{FF2B5EF4-FFF2-40B4-BE49-F238E27FC236}">
-                <a16:creationId xmlns:a16="http://schemas.microsoft.com/office/drawing/2014/main" id="{2041EC4C-171C-4DB2-B1CC-BF2FEFEB7A71}"/>
+                <a16:creationId xmlns:a16="http://schemas.microsoft.com/office/drawing/2014/main" id="{71CC0F1D-7CEE-4DE6-AB7E-D82CEBF77F9D}"/>
               </a:ext>
             </a:extLst>
           </p:cNvPr>
@@ -3310,7 +3310,7 @@
           <p:cNvPr id="9" name="">
             <a:extLst xmlns:a="http://schemas.openxmlformats.org/drawingml/2006/main">
               <a:ext uri="{FF2B5EF4-FFF2-40B4-BE49-F238E27FC236}">
-                <a16:creationId xmlns:a16="http://schemas.microsoft.com/office/drawing/2014/main" id="{5309564B-DABD-465A-AAE1-3E41E04CDC41}"/>
+                <a16:creationId xmlns:a16="http://schemas.microsoft.com/office/drawing/2014/main" id="{4FF06FD9-7744-4F84-8E41-D5B11D206990}"/>
               </a:ext>
             </a:extLst>
           </p:cNvPr>
@@ -3360,7 +3360,7 @@
           <p:cNvPr id="10" name="">
             <a:extLst xmlns:a="http://schemas.openxmlformats.org/drawingml/2006/main">
               <a:ext uri="{FF2B5EF4-FFF2-40B4-BE49-F238E27FC236}">
-                <a16:creationId xmlns:a16="http://schemas.microsoft.com/office/drawing/2014/main" id="{3B5B4BC7-6BC4-4429-9741-05708BAF7A49}"/>
+                <a16:creationId xmlns:a16="http://schemas.microsoft.com/office/drawing/2014/main" id="{385A6AEE-6AC6-423C-9F1C-34A5B231F01E}"/>
               </a:ext>
             </a:extLst>
           </p:cNvPr>
@@ -3395,7 +3395,7 @@
           <p:cNvPr id="11" name="">
             <a:extLst xmlns:a="http://schemas.openxmlformats.org/drawingml/2006/main">
               <a:ext uri="{FF2B5EF4-FFF2-40B4-BE49-F238E27FC236}">
-                <a16:creationId xmlns:a16="http://schemas.microsoft.com/office/drawing/2014/main" id="{5D0994BC-A1AD-4B54-B785-7E52E5204CC1}"/>
+                <a16:creationId xmlns:a16="http://schemas.microsoft.com/office/drawing/2014/main" id="{FCDE2446-AF72-41D3-A236-02AC37EA5CEF}"/>
               </a:ext>
             </a:extLst>
           </p:cNvPr>
@@ -3445,7 +3445,7 @@
           <p:cNvPr id="12" name="">
             <a:extLst xmlns:a="http://schemas.openxmlformats.org/drawingml/2006/main">
               <a:ext uri="{FF2B5EF4-FFF2-40B4-BE49-F238E27FC236}">
-                <a16:creationId xmlns:a16="http://schemas.microsoft.com/office/drawing/2014/main" id="{8A1879D4-D0B2-4470-B2B7-545060658B31}"/>
+                <a16:creationId xmlns:a16="http://schemas.microsoft.com/office/drawing/2014/main" id="{C36DD1CF-B8EB-4844-A26E-531FBD150337}"/>
               </a:ext>
             </a:extLst>
           </p:cNvPr>
@@ -3495,7 +3495,7 @@
           <p:cNvPr id="13" name="">
             <a:extLst xmlns:a="http://schemas.openxmlformats.org/drawingml/2006/main">
               <a:ext uri="{FF2B5EF4-FFF2-40B4-BE49-F238E27FC236}">
-                <a16:creationId xmlns:a16="http://schemas.microsoft.com/office/drawing/2014/main" id="{A4712C09-6B2F-4AE5-81F4-D7CC84109D0D}"/>
+                <a16:creationId xmlns:a16="http://schemas.microsoft.com/office/drawing/2014/main" id="{D8F9FA85-4368-4F43-BBE0-8EAD44E61075}"/>
               </a:ext>
             </a:extLst>
           </p:cNvPr>
@@ -3530,7 +3530,7 @@
           <p:cNvPr id="14" name="">
             <a:extLst xmlns:a="http://schemas.openxmlformats.org/drawingml/2006/main">
               <a:ext uri="{FF2B5EF4-FFF2-40B4-BE49-F238E27FC236}">
-                <a16:creationId xmlns:a16="http://schemas.microsoft.com/office/drawing/2014/main" id="{4420774C-55A2-4528-B8C1-2ECCDEB68817}"/>
+                <a16:creationId xmlns:a16="http://schemas.microsoft.com/office/drawing/2014/main" id="{AA28285B-B3D6-464A-8CCD-6E1237FF8277}"/>
               </a:ext>
             </a:extLst>
           </p:cNvPr>
@@ -3580,7 +3580,7 @@
           <p:cNvPr id="15" name="">
             <a:extLst xmlns:a="http://schemas.openxmlformats.org/drawingml/2006/main">
               <a:ext uri="{FF2B5EF4-FFF2-40B4-BE49-F238E27FC236}">
-                <a16:creationId xmlns:a16="http://schemas.microsoft.com/office/drawing/2014/main" id="{4ACED480-DE4A-4A6F-AD68-F4F268443D75}"/>
+                <a16:creationId xmlns:a16="http://schemas.microsoft.com/office/drawing/2014/main" id="{2EF7E38C-32D2-41F2-AA1F-649869ED7E23}"/>
               </a:ext>
             </a:extLst>
           </p:cNvPr>
@@ -3630,7 +3630,7 @@
           <p:cNvPr id="16" name="">
             <a:extLst xmlns:a="http://schemas.openxmlformats.org/drawingml/2006/main">
               <a:ext uri="{FF2B5EF4-FFF2-40B4-BE49-F238E27FC236}">
-                <a16:creationId xmlns:a16="http://schemas.microsoft.com/office/drawing/2014/main" id="{D5FA565E-7C5D-41FB-82C0-1785F1E7735C}"/>
+                <a16:creationId xmlns:a16="http://schemas.microsoft.com/office/drawing/2014/main" id="{E7438C53-6F3C-47B6-B51A-FF8F4338F502}"/>
               </a:ext>
             </a:extLst>
           </p:cNvPr>
@@ -3665,7 +3665,7 @@
           <p:cNvPr id="17" name="">
             <a:extLst xmlns:a="http://schemas.openxmlformats.org/drawingml/2006/main">
               <a:ext uri="{FF2B5EF4-FFF2-40B4-BE49-F238E27FC236}">
-                <a16:creationId xmlns:a16="http://schemas.microsoft.com/office/drawing/2014/main" id="{E352DAF1-A6E2-4356-84CC-9FF8D3956EA5}"/>
+                <a16:creationId xmlns:a16="http://schemas.microsoft.com/office/drawing/2014/main" id="{4DD015F9-5084-4B75-A5FD-DD52DA2BD7B1}"/>
               </a:ext>
             </a:extLst>
           </p:cNvPr>
@@ -3715,7 +3715,7 @@
           <p:cNvPr id="18" name="">
             <a:extLst xmlns:a="http://schemas.openxmlformats.org/drawingml/2006/main">
               <a:ext uri="{FF2B5EF4-FFF2-40B4-BE49-F238E27FC236}">
-                <a16:creationId xmlns:a16="http://schemas.microsoft.com/office/drawing/2014/main" id="{269BD9B4-EE77-4835-8A25-04CD3B6FDDD0}"/>
+                <a16:creationId xmlns:a16="http://schemas.microsoft.com/office/drawing/2014/main" id="{2CC558B1-D6F3-4F62-BD8E-F7A3CA18FCEE}"/>
               </a:ext>
             </a:extLst>
           </p:cNvPr>
@@ -3765,7 +3765,7 @@
           <p:cNvPr id="19" name="">
             <a:extLst xmlns:a="http://schemas.openxmlformats.org/drawingml/2006/main">
               <a:ext uri="{FF2B5EF4-FFF2-40B4-BE49-F238E27FC236}">
-                <a16:creationId xmlns:a16="http://schemas.microsoft.com/office/drawing/2014/main" id="{BB61C85A-6BF9-487D-9CC2-D05A8C323BD8}"/>
+                <a16:creationId xmlns:a16="http://schemas.microsoft.com/office/drawing/2014/main" id="{C978E366-E072-4544-935A-5D4E3D7B9D85}"/>
               </a:ext>
             </a:extLst>
           </p:cNvPr>
@@ -3800,7 +3800,7 @@
           <p:cNvPr id="20" name="">
             <a:extLst xmlns:a="http://schemas.openxmlformats.org/drawingml/2006/main">
               <a:ext uri="{FF2B5EF4-FFF2-40B4-BE49-F238E27FC236}">
-                <a16:creationId xmlns:a16="http://schemas.microsoft.com/office/drawing/2014/main" id="{BFF24D80-C630-4FD6-8F9A-1CD2DBCE3AD5}"/>
+                <a16:creationId xmlns:a16="http://schemas.microsoft.com/office/drawing/2014/main" id="{489424E8-B9D9-4E3B-B2A1-3407747673FE}"/>
               </a:ext>
             </a:extLst>
           </p:cNvPr>
@@ -3850,7 +3850,7 @@
           <p:cNvPr id="21" name="">
             <a:extLst xmlns:a="http://schemas.openxmlformats.org/drawingml/2006/main">
               <a:ext uri="{FF2B5EF4-FFF2-40B4-BE49-F238E27FC236}">
-                <a16:creationId xmlns:a16="http://schemas.microsoft.com/office/drawing/2014/main" id="{C4F8C889-56F7-42D8-80E3-8E42B66059DA}"/>
+                <a16:creationId xmlns:a16="http://schemas.microsoft.com/office/drawing/2014/main" id="{DF5C9D22-E39A-454A-BEAB-88371B001937}"/>
               </a:ext>
             </a:extLst>
           </p:cNvPr>
@@ -3900,7 +3900,7 @@
           <p:cNvPr id="22" name="">
             <a:extLst xmlns:a="http://schemas.openxmlformats.org/drawingml/2006/main">
               <a:ext uri="{FF2B5EF4-FFF2-40B4-BE49-F238E27FC236}">
-                <a16:creationId xmlns:a16="http://schemas.microsoft.com/office/drawing/2014/main" id="{9476C6B9-772F-4031-8CFE-FAFF88CF88EA}"/>
+                <a16:creationId xmlns:a16="http://schemas.microsoft.com/office/drawing/2014/main" id="{67D843FE-6ECF-45AA-A49A-CA0D4AAB40C6}"/>
               </a:ext>
             </a:extLst>
           </p:cNvPr>
@@ -3950,7 +3950,7 @@
           <p:cNvPr id="23" name="">
             <a:extLst xmlns:a="http://schemas.openxmlformats.org/drawingml/2006/main">
               <a:ext uri="{FF2B5EF4-FFF2-40B4-BE49-F238E27FC236}">
-                <a16:creationId xmlns:a16="http://schemas.microsoft.com/office/drawing/2014/main" id="{462A9775-52C7-4AA5-B099-4963D0653119}"/>
+                <a16:creationId xmlns:a16="http://schemas.microsoft.com/office/drawing/2014/main" id="{F1D408E8-7CD0-4E4F-A4B8-800F0DAEA05E}"/>
               </a:ext>
             </a:extLst>
           </p:cNvPr>
@@ -3983,7 +3983,7 @@
           <p:cNvPr id="24" name="">
             <a:extLst xmlns:a="http://schemas.openxmlformats.org/drawingml/2006/main">
               <a:ext uri="{FF2B5EF4-FFF2-40B4-BE49-F238E27FC236}">
-                <a16:creationId xmlns:a16="http://schemas.microsoft.com/office/drawing/2014/main" id="{0FC23C80-364F-4948-95C2-28EF289F825E}"/>
+                <a16:creationId xmlns:a16="http://schemas.microsoft.com/office/drawing/2014/main" id="{B3C992D1-92D9-461D-9674-C603A7692AEB}"/>
               </a:ext>
             </a:extLst>
           </p:cNvPr>
@@ -4016,7 +4016,7 @@
           <p:cNvPr id="25" name="">
             <a:extLst xmlns:a="http://schemas.openxmlformats.org/drawingml/2006/main">
               <a:ext uri="{FF2B5EF4-FFF2-40B4-BE49-F238E27FC236}">
-                <a16:creationId xmlns:a16="http://schemas.microsoft.com/office/drawing/2014/main" id="{4E4CF0F7-C17D-417C-AF50-DC6CA2FC2121}"/>
+                <a16:creationId xmlns:a16="http://schemas.microsoft.com/office/drawing/2014/main" id="{7C98CD82-F65E-4773-B7D6-7FFD703C70DA}"/>
               </a:ext>
             </a:extLst>
           </p:cNvPr>
@@ -4064,7 +4064,7 @@
     </p:spTree>
     <p:extLst>
       <p:ext uri="{BB962C8B-B14F-4D97-AF65-F5344CB8AC3E}">
-        <p14:creationId xmlns:p14="http://schemas.microsoft.com/office/powerpoint/2010/main" val="1346342320"/>
+        <p14:creationId xmlns:p14="http://schemas.microsoft.com/office/powerpoint/2010/main" val="249688512"/>
       </p:ext>
     </p:extLst>
   </p:cSld>
@@ -4095,7 +4095,7 @@
           <p:cNvPr id="7" name="">
             <a:extLst xmlns:a="http://schemas.openxmlformats.org/drawingml/2006/main">
               <a:ext uri="{FF2B5EF4-FFF2-40B4-BE49-F238E27FC236}">
-                <a16:creationId xmlns:a16="http://schemas.microsoft.com/office/drawing/2014/main" id="{1FC9E5A0-72EE-43E9-A4B6-F629162BC76A}"/>
+                <a16:creationId xmlns:a16="http://schemas.microsoft.com/office/drawing/2014/main" id="{BF5206E0-8F79-4E66-A7B5-F088035EFFA3}"/>
               </a:ext>
             </a:extLst>
           </p:cNvPr>
@@ -4135,7 +4135,7 @@
                   <a:srgbClr val="ED5A53"/>
                 </a:solidFill>
               </a:rPr>
-              <a:t>EARLY-SIGNAL RADAR</a:t>
+              <a:t>RELEASE RADAR</a:t>
             </a:r>
           </a:p>
         </p:txBody>
@@ -4145,7 +4145,7 @@
           <p:cNvPr id="2" name="">
             <a:extLst xmlns:a="http://schemas.openxmlformats.org/drawingml/2006/main">
               <a:ext uri="{FF2B5EF4-FFF2-40B4-BE49-F238E27FC236}">
-                <a16:creationId xmlns:a16="http://schemas.microsoft.com/office/drawing/2014/main" id="{1F47801B-DC28-4054-B4EC-2B100EFACF53}"/>
+                <a16:creationId xmlns:a16="http://schemas.microsoft.com/office/drawing/2014/main" id="{AA7D5350-5067-44F6-8C57-F25871DCF710}"/>
               </a:ext>
             </a:extLst>
           </p:cNvPr>
@@ -4199,7 +4199,7 @@
           <p:nvPr/>
         </p:nvPicPr>
         <p:blipFill>
-          <a:blip xmlns:r="http://schemas.openxmlformats.org/officeDocument/2006/relationships" xmlns:a="http://schemas.openxmlformats.org/drawingml/2006/main" r:embed="Red2f2662f3cd48be"/>
+          <a:blip xmlns:r="http://schemas.openxmlformats.org/officeDocument/2006/relationships" xmlns:a="http://schemas.openxmlformats.org/drawingml/2006/main" r:embed="Rea31dae1aff24973"/>
           <a:srcRect xmlns:a="http://schemas.openxmlformats.org/drawingml/2006/main" l="0" t="22569" r="0" b="22569"/>
           <a:stretch xmlns:a="http://schemas.openxmlformats.org/drawingml/2006/main">
             <a:fillRect l="0" t="0" r="0" b="0"/>
@@ -4222,7 +4222,7 @@
           <p:cNvPr id="4" name="">
             <a:extLst xmlns:a="http://schemas.openxmlformats.org/drawingml/2006/main">
               <a:ext uri="{FF2B5EF4-FFF2-40B4-BE49-F238E27FC236}">
-                <a16:creationId xmlns:a16="http://schemas.microsoft.com/office/drawing/2014/main" id="{B103B16A-203A-44CA-93B5-16090A4FAB6D}"/>
+                <a16:creationId xmlns:a16="http://schemas.microsoft.com/office/drawing/2014/main" id="{69A3331A-95F3-45A4-8BE1-1B43B9D84724}"/>
               </a:ext>
             </a:extLst>
           </p:cNvPr>
@@ -4255,7 +4255,7 @@
           <p:cNvPr id="5" name="">
             <a:extLst xmlns:a="http://schemas.openxmlformats.org/drawingml/2006/main">
               <a:ext uri="{FF2B5EF4-FFF2-40B4-BE49-F238E27FC236}">
-                <a16:creationId xmlns:a16="http://schemas.microsoft.com/office/drawing/2014/main" id="{0FBBEFEA-D3B0-4FBA-BA22-378380065DA4}"/>
+                <a16:creationId xmlns:a16="http://schemas.microsoft.com/office/drawing/2014/main" id="{6EFE9473-613C-425C-9872-99EF00EADDA0}"/>
               </a:ext>
             </a:extLst>
           </p:cNvPr>
@@ -4288,7 +4288,7 @@
           <p:cNvPr id="6" name="">
             <a:extLst xmlns:a="http://schemas.openxmlformats.org/drawingml/2006/main">
               <a:ext uri="{FF2B5EF4-FFF2-40B4-BE49-F238E27FC236}">
-                <a16:creationId xmlns:a16="http://schemas.microsoft.com/office/drawing/2014/main" id="{74631DFF-0C0C-4A1F-9C10-D381982D3913}"/>
+                <a16:creationId xmlns:a16="http://schemas.microsoft.com/office/drawing/2014/main" id="{CAF81DFA-988E-4307-BADC-1B51335B6C97}"/>
               </a:ext>
             </a:extLst>
           </p:cNvPr>
@@ -4336,7 +4336,7 @@
     </p:spTree>
     <p:extLst>
       <p:ext uri="{BB962C8B-B14F-4D97-AF65-F5344CB8AC3E}">
-        <p14:creationId xmlns:p14="http://schemas.microsoft.com/office/powerpoint/2010/main" val="1045573701"/>
+        <p14:creationId xmlns:p14="http://schemas.microsoft.com/office/powerpoint/2010/main" val="1485729444"/>
       </p:ext>
     </p:extLst>
   </p:cSld>
@@ -4367,7 +4367,7 @@
           <p:cNvPr id="15" name="">
             <a:extLst xmlns:a="http://schemas.openxmlformats.org/drawingml/2006/main">
               <a:ext uri="{FF2B5EF4-FFF2-40B4-BE49-F238E27FC236}">
-                <a16:creationId xmlns:a16="http://schemas.microsoft.com/office/drawing/2014/main" id="{6BE037E9-CEB9-428A-A3E1-69F3D07F599C}"/>
+                <a16:creationId xmlns:a16="http://schemas.microsoft.com/office/drawing/2014/main" id="{DAF17C4B-FA03-42CF-A109-5FCC55BD5949}"/>
               </a:ext>
             </a:extLst>
           </p:cNvPr>
@@ -4417,7 +4417,7 @@
           <p:cNvPr id="2" name="">
             <a:extLst xmlns:a="http://schemas.openxmlformats.org/drawingml/2006/main">
               <a:ext uri="{FF2B5EF4-FFF2-40B4-BE49-F238E27FC236}">
-                <a16:creationId xmlns:a16="http://schemas.microsoft.com/office/drawing/2014/main" id="{0BA31CAF-4612-4307-B37C-6AE81A5B6BD1}"/>
+                <a16:creationId xmlns:a16="http://schemas.microsoft.com/office/drawing/2014/main" id="{F164E6B1-6060-40B6-8242-146286F81579}"/>
               </a:ext>
             </a:extLst>
           </p:cNvPr>
@@ -4467,7 +4467,7 @@
           <p:cNvPr id="3" name="">
             <a:extLst xmlns:a="http://schemas.openxmlformats.org/drawingml/2006/main">
               <a:ext uri="{FF2B5EF4-FFF2-40B4-BE49-F238E27FC236}">
-                <a16:creationId xmlns:a16="http://schemas.microsoft.com/office/drawing/2014/main" id="{7F1FC595-E150-4704-9830-94F27CAE9A48}"/>
+                <a16:creationId xmlns:a16="http://schemas.microsoft.com/office/drawing/2014/main" id="{CAFA844E-559E-45E9-988B-9A150CA01B1B}"/>
               </a:ext>
             </a:extLst>
           </p:cNvPr>
@@ -4502,7 +4502,7 @@
           <p:cNvPr id="4" name="">
             <a:extLst xmlns:a="http://schemas.openxmlformats.org/drawingml/2006/main">
               <a:ext uri="{FF2B5EF4-FFF2-40B4-BE49-F238E27FC236}">
-                <a16:creationId xmlns:a16="http://schemas.microsoft.com/office/drawing/2014/main" id="{755A988B-95BB-440B-9E70-849B52FF8A73}"/>
+                <a16:creationId xmlns:a16="http://schemas.microsoft.com/office/drawing/2014/main" id="{398CBEF9-AE34-4244-AC0B-73A91CB7700F}"/>
               </a:ext>
             </a:extLst>
           </p:cNvPr>
@@ -4552,7 +4552,7 @@
           <p:cNvPr id="5" name="">
             <a:extLst xmlns:a="http://schemas.openxmlformats.org/drawingml/2006/main">
               <a:ext uri="{FF2B5EF4-FFF2-40B4-BE49-F238E27FC236}">
-                <a16:creationId xmlns:a16="http://schemas.microsoft.com/office/drawing/2014/main" id="{AACC3F51-C12D-4CA2-8AB7-76618B268469}"/>
+                <a16:creationId xmlns:a16="http://schemas.microsoft.com/office/drawing/2014/main" id="{FF6A3B80-8036-45DA-A86C-3941011AE2AD}"/>
               </a:ext>
             </a:extLst>
           </p:cNvPr>
@@ -4602,7 +4602,7 @@
           <p:cNvPr id="6" name="">
             <a:extLst xmlns:a="http://schemas.openxmlformats.org/drawingml/2006/main">
               <a:ext uri="{FF2B5EF4-FFF2-40B4-BE49-F238E27FC236}">
-                <a16:creationId xmlns:a16="http://schemas.microsoft.com/office/drawing/2014/main" id="{6CE98488-EC7B-48BF-BEF3-8EC901A8AB7D}"/>
+                <a16:creationId xmlns:a16="http://schemas.microsoft.com/office/drawing/2014/main" id="{97EEB66B-A029-4F02-BA2A-4F373D234F77}"/>
               </a:ext>
             </a:extLst>
           </p:cNvPr>
@@ -4652,7 +4652,7 @@
           <p:cNvPr id="7" name="">
             <a:extLst xmlns:a="http://schemas.openxmlformats.org/drawingml/2006/main">
               <a:ext uri="{FF2B5EF4-FFF2-40B4-BE49-F238E27FC236}">
-                <a16:creationId xmlns:a16="http://schemas.microsoft.com/office/drawing/2014/main" id="{BC15DD4A-4BC1-49D9-9F92-61C67C5F73D2}"/>
+                <a16:creationId xmlns:a16="http://schemas.microsoft.com/office/drawing/2014/main" id="{56881CBA-89C5-4E97-AC3D-E3B9BA33EFBC}"/>
               </a:ext>
             </a:extLst>
           </p:cNvPr>
@@ -4702,7 +4702,7 @@
           <p:cNvPr id="8" name="">
             <a:extLst xmlns:a="http://schemas.openxmlformats.org/drawingml/2006/main">
               <a:ext uri="{FF2B5EF4-FFF2-40B4-BE49-F238E27FC236}">
-                <a16:creationId xmlns:a16="http://schemas.microsoft.com/office/drawing/2014/main" id="{A7FD04AC-2855-4706-9BB9-19360438608B}"/>
+                <a16:creationId xmlns:a16="http://schemas.microsoft.com/office/drawing/2014/main" id="{FC71AE41-A0C5-49F1-9EAC-A7FEF0C29A67}"/>
               </a:ext>
             </a:extLst>
           </p:cNvPr>
@@ -4752,7 +4752,7 @@
           <p:cNvPr id="9" name="">
             <a:extLst xmlns:a="http://schemas.openxmlformats.org/drawingml/2006/main">
               <a:ext uri="{FF2B5EF4-FFF2-40B4-BE49-F238E27FC236}">
-                <a16:creationId xmlns:a16="http://schemas.microsoft.com/office/drawing/2014/main" id="{8F26FAD9-E982-4FC3-BEC4-05A2D25E6FCA}"/>
+                <a16:creationId xmlns:a16="http://schemas.microsoft.com/office/drawing/2014/main" id="{96838A31-E45B-4859-8092-1BD4B66F296D}"/>
               </a:ext>
             </a:extLst>
           </p:cNvPr>
@@ -4802,7 +4802,7 @@
           <p:cNvPr id="10" name="">
             <a:extLst xmlns:a="http://schemas.openxmlformats.org/drawingml/2006/main">
               <a:ext uri="{FF2B5EF4-FFF2-40B4-BE49-F238E27FC236}">
-                <a16:creationId xmlns:a16="http://schemas.microsoft.com/office/drawing/2014/main" id="{F552049A-093C-478C-B366-F2D03ED96060}"/>
+                <a16:creationId xmlns:a16="http://schemas.microsoft.com/office/drawing/2014/main" id="{31F584B7-88A8-45C4-8B8C-E838D267A39A}"/>
               </a:ext>
             </a:extLst>
           </p:cNvPr>
@@ -4856,7 +4856,7 @@
           <p:nvPr/>
         </p:nvPicPr>
         <p:blipFill>
-          <a:blip xmlns:r="http://schemas.openxmlformats.org/officeDocument/2006/relationships" xmlns:a="http://schemas.openxmlformats.org/drawingml/2006/main" r:embed="R694c5e74f0e34b27"/>
+          <a:blip xmlns:r="http://schemas.openxmlformats.org/officeDocument/2006/relationships" xmlns:a="http://schemas.openxmlformats.org/drawingml/2006/main" r:embed="Rcff84a05d39a4dfd"/>
           <a:srcRect xmlns:a="http://schemas.openxmlformats.org/drawingml/2006/main" l="0" t="1955" r="0" b="1955"/>
           <a:stretch xmlns:a="http://schemas.openxmlformats.org/drawingml/2006/main">
             <a:fillRect l="0" t="0" r="0" b="0"/>
@@ -4879,7 +4879,7 @@
           <p:cNvPr id="12" name="">
             <a:extLst xmlns:a="http://schemas.openxmlformats.org/drawingml/2006/main">
               <a:ext uri="{FF2B5EF4-FFF2-40B4-BE49-F238E27FC236}">
-                <a16:creationId xmlns:a16="http://schemas.microsoft.com/office/drawing/2014/main" id="{E1D5C294-EFDB-4187-8345-319A12E71669}"/>
+                <a16:creationId xmlns:a16="http://schemas.microsoft.com/office/drawing/2014/main" id="{FDDE9791-F381-49B9-9734-7533872DB82F}"/>
               </a:ext>
             </a:extLst>
           </p:cNvPr>
@@ -4912,7 +4912,7 @@
           <p:cNvPr id="13" name="">
             <a:extLst xmlns:a="http://schemas.openxmlformats.org/drawingml/2006/main">
               <a:ext uri="{FF2B5EF4-FFF2-40B4-BE49-F238E27FC236}">
-                <a16:creationId xmlns:a16="http://schemas.microsoft.com/office/drawing/2014/main" id="{94B4679C-2C88-4CFF-8034-058C833A05AD}"/>
+                <a16:creationId xmlns:a16="http://schemas.microsoft.com/office/drawing/2014/main" id="{470A1BAA-E267-4F63-836D-D0A1C65A5EAA}"/>
               </a:ext>
             </a:extLst>
           </p:cNvPr>
@@ -4945,7 +4945,7 @@
           <p:cNvPr id="14" name="">
             <a:extLst xmlns:a="http://schemas.openxmlformats.org/drawingml/2006/main">
               <a:ext uri="{FF2B5EF4-FFF2-40B4-BE49-F238E27FC236}">
-                <a16:creationId xmlns:a16="http://schemas.microsoft.com/office/drawing/2014/main" id="{AA16EDD9-F3A5-47C1-B39C-265FF7190E21}"/>
+                <a16:creationId xmlns:a16="http://schemas.microsoft.com/office/drawing/2014/main" id="{BA989F19-8F0A-4BD6-8C47-4C768E3FDD66}"/>
               </a:ext>
             </a:extLst>
           </p:cNvPr>
@@ -4993,7 +4993,7 @@
     </p:spTree>
     <p:extLst>
       <p:ext uri="{BB962C8B-B14F-4D97-AF65-F5344CB8AC3E}">
-        <p14:creationId xmlns:p14="http://schemas.microsoft.com/office/powerpoint/2010/main" val="178269385"/>
+        <p14:creationId xmlns:p14="http://schemas.microsoft.com/office/powerpoint/2010/main" val="1139786538"/>
       </p:ext>
     </p:extLst>
   </p:cSld>
@@ -5024,7 +5024,7 @@
           <p:cNvPr id="22" name="">
             <a:extLst xmlns:a="http://schemas.openxmlformats.org/drawingml/2006/main">
               <a:ext uri="{FF2B5EF4-FFF2-40B4-BE49-F238E27FC236}">
-                <a16:creationId xmlns:a16="http://schemas.microsoft.com/office/drawing/2014/main" id="{6B8646C5-11FD-44B3-A7E9-477CC96744FF}"/>
+                <a16:creationId xmlns:a16="http://schemas.microsoft.com/office/drawing/2014/main" id="{C2993442-47DE-4F67-AF90-212CC65544EA}"/>
               </a:ext>
             </a:extLst>
           </p:cNvPr>
@@ -5074,7 +5074,7 @@
           <p:cNvPr id="2" name="">
             <a:extLst xmlns:a="http://schemas.openxmlformats.org/drawingml/2006/main">
               <a:ext uri="{FF2B5EF4-FFF2-40B4-BE49-F238E27FC236}">
-                <a16:creationId xmlns:a16="http://schemas.microsoft.com/office/drawing/2014/main" id="{077D4CBA-1D6F-4143-A644-5B47CF14CD84}"/>
+                <a16:creationId xmlns:a16="http://schemas.microsoft.com/office/drawing/2014/main" id="{728D88B9-7E07-45F6-B3EF-7029BC393C4B}"/>
               </a:ext>
             </a:extLst>
           </p:cNvPr>
@@ -5124,7 +5124,7 @@
           <p:cNvPr id="3" name="">
             <a:extLst xmlns:a="http://schemas.openxmlformats.org/drawingml/2006/main">
               <a:ext uri="{FF2B5EF4-FFF2-40B4-BE49-F238E27FC236}">
-                <a16:creationId xmlns:a16="http://schemas.microsoft.com/office/drawing/2014/main" id="{8213B740-0679-44CB-8EC3-0258203EB78D}"/>
+                <a16:creationId xmlns:a16="http://schemas.microsoft.com/office/drawing/2014/main" id="{6222782B-D1C5-4FFD-A1EB-C7D142F0D6A8}"/>
               </a:ext>
             </a:extLst>
           </p:cNvPr>
@@ -5157,7 +5157,7 @@
           <p:cNvPr id="4" name="">
             <a:extLst xmlns:a="http://schemas.openxmlformats.org/drawingml/2006/main">
               <a:ext uri="{FF2B5EF4-FFF2-40B4-BE49-F238E27FC236}">
-                <a16:creationId xmlns:a16="http://schemas.microsoft.com/office/drawing/2014/main" id="{FC89CF4E-5F39-4BC7-8F8D-2512FAF28197}"/>
+                <a16:creationId xmlns:a16="http://schemas.microsoft.com/office/drawing/2014/main" id="{D910D289-F921-4384-B976-3542EAE073B1}"/>
               </a:ext>
             </a:extLst>
           </p:cNvPr>
@@ -5190,7 +5190,7 @@
           <p:cNvPr id="5" name="">
             <a:extLst xmlns:a="http://schemas.openxmlformats.org/drawingml/2006/main">
               <a:ext uri="{FF2B5EF4-FFF2-40B4-BE49-F238E27FC236}">
-                <a16:creationId xmlns:a16="http://schemas.microsoft.com/office/drawing/2014/main" id="{8A2516F1-89C4-47CE-B0F0-4659A7656000}"/>
+                <a16:creationId xmlns:a16="http://schemas.microsoft.com/office/drawing/2014/main" id="{20283021-F78E-45CC-A414-EC4328634167}"/>
               </a:ext>
             </a:extLst>
           </p:cNvPr>
@@ -5223,7 +5223,7 @@
           <p:cNvPr id="6" name="">
             <a:extLst xmlns:a="http://schemas.openxmlformats.org/drawingml/2006/main">
               <a:ext uri="{FF2B5EF4-FFF2-40B4-BE49-F238E27FC236}">
-                <a16:creationId xmlns:a16="http://schemas.microsoft.com/office/drawing/2014/main" id="{595DBFC2-3E64-4E7B-B4AC-06CCBECCE847}"/>
+                <a16:creationId xmlns:a16="http://schemas.microsoft.com/office/drawing/2014/main" id="{25A8685C-9761-4BE0-9523-4466F01FAAAB}"/>
               </a:ext>
             </a:extLst>
           </p:cNvPr>
@@ -5256,7 +5256,7 @@
           <p:cNvPr id="7" name="">
             <a:extLst xmlns:a="http://schemas.openxmlformats.org/drawingml/2006/main">
               <a:ext uri="{FF2B5EF4-FFF2-40B4-BE49-F238E27FC236}">
-                <a16:creationId xmlns:a16="http://schemas.microsoft.com/office/drawing/2014/main" id="{B0D092D4-FA62-4BF8-B97E-86792FABAF04}"/>
+                <a16:creationId xmlns:a16="http://schemas.microsoft.com/office/drawing/2014/main" id="{55049D2F-49C4-47B6-AA95-44A48F7C6FC3}"/>
               </a:ext>
             </a:extLst>
           </p:cNvPr>
@@ -5289,7 +5289,7 @@
           <p:cNvPr id="8" name="">
             <a:extLst xmlns:a="http://schemas.openxmlformats.org/drawingml/2006/main">
               <a:ext uri="{FF2B5EF4-FFF2-40B4-BE49-F238E27FC236}">
-                <a16:creationId xmlns:a16="http://schemas.microsoft.com/office/drawing/2014/main" id="{F405C891-692E-4A32-9492-E9408EC4F61E}"/>
+                <a16:creationId xmlns:a16="http://schemas.microsoft.com/office/drawing/2014/main" id="{85021AC5-338F-401D-8B95-216145C7C327}"/>
               </a:ext>
             </a:extLst>
           </p:cNvPr>
@@ -5356,7 +5356,7 @@
           <p:cNvPr id="9" name="">
             <a:extLst xmlns:a="http://schemas.openxmlformats.org/drawingml/2006/main">
               <a:ext uri="{FF2B5EF4-FFF2-40B4-BE49-F238E27FC236}">
-                <a16:creationId xmlns:a16="http://schemas.microsoft.com/office/drawing/2014/main" id="{B012C87F-3CB5-4840-89A9-AA547B4C8AD6}"/>
+                <a16:creationId xmlns:a16="http://schemas.microsoft.com/office/drawing/2014/main" id="{002C9AD9-B0C8-4D63-934C-8601D2758B52}"/>
               </a:ext>
             </a:extLst>
           </p:cNvPr>
@@ -5389,7 +5389,7 @@
           <p:cNvPr id="10" name="">
             <a:extLst xmlns:a="http://schemas.openxmlformats.org/drawingml/2006/main">
               <a:ext uri="{FF2B5EF4-FFF2-40B4-BE49-F238E27FC236}">
-                <a16:creationId xmlns:a16="http://schemas.microsoft.com/office/drawing/2014/main" id="{51427055-D05D-4613-A19E-837730AAA09E}"/>
+                <a16:creationId xmlns:a16="http://schemas.microsoft.com/office/drawing/2014/main" id="{92FF975D-7DB4-4128-BF4E-5BE2DBC4F475}"/>
               </a:ext>
             </a:extLst>
           </p:cNvPr>
@@ -5439,7 +5439,7 @@
           <p:cNvPr id="11" name="">
             <a:extLst xmlns:a="http://schemas.openxmlformats.org/drawingml/2006/main">
               <a:ext uri="{FF2B5EF4-FFF2-40B4-BE49-F238E27FC236}">
-                <a16:creationId xmlns:a16="http://schemas.microsoft.com/office/drawing/2014/main" id="{7DE14660-A0A1-4401-AF65-E94C8221BEE2}"/>
+                <a16:creationId xmlns:a16="http://schemas.microsoft.com/office/drawing/2014/main" id="{3F157F94-5FE6-46D0-853F-EB4522BBAB46}"/>
               </a:ext>
             </a:extLst>
           </p:cNvPr>
@@ -5472,7 +5472,7 @@
           <p:cNvPr id="12" name="">
             <a:extLst xmlns:a="http://schemas.openxmlformats.org/drawingml/2006/main">
               <a:ext uri="{FF2B5EF4-FFF2-40B4-BE49-F238E27FC236}">
-                <a16:creationId xmlns:a16="http://schemas.microsoft.com/office/drawing/2014/main" id="{BDFC20C0-0C39-444D-AB01-273BCDE4028B}"/>
+                <a16:creationId xmlns:a16="http://schemas.microsoft.com/office/drawing/2014/main" id="{47286C36-8009-4611-B9D5-2A5FE54B8F6C}"/>
               </a:ext>
             </a:extLst>
           </p:cNvPr>
@@ -5522,7 +5522,7 @@
           <p:cNvPr id="13" name="">
             <a:extLst xmlns:a="http://schemas.openxmlformats.org/drawingml/2006/main">
               <a:ext uri="{FF2B5EF4-FFF2-40B4-BE49-F238E27FC236}">
-                <a16:creationId xmlns:a16="http://schemas.microsoft.com/office/drawing/2014/main" id="{E2B95240-06D0-4B50-932C-FEAA4DA6CBF4}"/>
+                <a16:creationId xmlns:a16="http://schemas.microsoft.com/office/drawing/2014/main" id="{3F6CCB9D-F474-4430-953C-6B1520311FCF}"/>
               </a:ext>
             </a:extLst>
           </p:cNvPr>
@@ -5555,7 +5555,7 @@
           <p:cNvPr id="14" name="">
             <a:extLst xmlns:a="http://schemas.openxmlformats.org/drawingml/2006/main">
               <a:ext uri="{FF2B5EF4-FFF2-40B4-BE49-F238E27FC236}">
-                <a16:creationId xmlns:a16="http://schemas.microsoft.com/office/drawing/2014/main" id="{BC3D1205-E198-4693-9193-85E0299AF7B9}"/>
+                <a16:creationId xmlns:a16="http://schemas.microsoft.com/office/drawing/2014/main" id="{2E5BFF07-452C-4A6A-8AF0-DD16F30DBD48}"/>
               </a:ext>
             </a:extLst>
           </p:cNvPr>
@@ -5605,7 +5605,7 @@
           <p:cNvPr id="15" name="">
             <a:extLst xmlns:a="http://schemas.openxmlformats.org/drawingml/2006/main">
               <a:ext uri="{FF2B5EF4-FFF2-40B4-BE49-F238E27FC236}">
-                <a16:creationId xmlns:a16="http://schemas.microsoft.com/office/drawing/2014/main" id="{78FE2F3E-DFA1-4E2F-97FC-4DD5EF6DD951}"/>
+                <a16:creationId xmlns:a16="http://schemas.microsoft.com/office/drawing/2014/main" id="{2CCBC313-2C50-43AA-8D0F-63AB7888A218}"/>
               </a:ext>
             </a:extLst>
           </p:cNvPr>
@@ -5638,7 +5638,7 @@
           <p:cNvPr id="16" name="">
             <a:extLst xmlns:a="http://schemas.openxmlformats.org/drawingml/2006/main">
               <a:ext uri="{FF2B5EF4-FFF2-40B4-BE49-F238E27FC236}">
-                <a16:creationId xmlns:a16="http://schemas.microsoft.com/office/drawing/2014/main" id="{3AA391F6-5F17-481E-AB22-2610A1875C11}"/>
+                <a16:creationId xmlns:a16="http://schemas.microsoft.com/office/drawing/2014/main" id="{EEFD3933-4306-43D2-A9A2-31CCED3659A4}"/>
               </a:ext>
             </a:extLst>
           </p:cNvPr>
@@ -5688,7 +5688,7 @@
           <p:cNvPr id="17" name="">
             <a:extLst xmlns:a="http://schemas.openxmlformats.org/drawingml/2006/main">
               <a:ext uri="{FF2B5EF4-FFF2-40B4-BE49-F238E27FC236}">
-                <a16:creationId xmlns:a16="http://schemas.microsoft.com/office/drawing/2014/main" id="{32749B1E-765C-4EE1-B346-D022997F2629}"/>
+                <a16:creationId xmlns:a16="http://schemas.microsoft.com/office/drawing/2014/main" id="{F69BEFA9-D90D-4296-AC00-A1E6427621F3}"/>
               </a:ext>
             </a:extLst>
           </p:cNvPr>
@@ -5721,7 +5721,7 @@
           <p:cNvPr id="18" name="">
             <a:extLst xmlns:a="http://schemas.openxmlformats.org/drawingml/2006/main">
               <a:ext uri="{FF2B5EF4-FFF2-40B4-BE49-F238E27FC236}">
-                <a16:creationId xmlns:a16="http://schemas.microsoft.com/office/drawing/2014/main" id="{F96D7F70-552D-42A6-8A5E-805CB8E88E36}"/>
+                <a16:creationId xmlns:a16="http://schemas.microsoft.com/office/drawing/2014/main" id="{20713393-3A37-440F-BBC1-E086CA791B49}"/>
               </a:ext>
             </a:extLst>
           </p:cNvPr>
@@ -5771,7 +5771,7 @@
           <p:cNvPr id="19" name="">
             <a:extLst xmlns:a="http://schemas.openxmlformats.org/drawingml/2006/main">
               <a:ext uri="{FF2B5EF4-FFF2-40B4-BE49-F238E27FC236}">
-                <a16:creationId xmlns:a16="http://schemas.microsoft.com/office/drawing/2014/main" id="{A79AC982-D12F-43BD-BCD9-41D856155D2D}"/>
+                <a16:creationId xmlns:a16="http://schemas.microsoft.com/office/drawing/2014/main" id="{197E9A6C-6546-4CCD-8C06-8AB48C9470BB}"/>
               </a:ext>
             </a:extLst>
           </p:cNvPr>
@@ -5804,7 +5804,7 @@
           <p:cNvPr id="20" name="">
             <a:extLst xmlns:a="http://schemas.openxmlformats.org/drawingml/2006/main">
               <a:ext uri="{FF2B5EF4-FFF2-40B4-BE49-F238E27FC236}">
-                <a16:creationId xmlns:a16="http://schemas.microsoft.com/office/drawing/2014/main" id="{8BF888E5-CC79-4B01-8878-044AE4258477}"/>
+                <a16:creationId xmlns:a16="http://schemas.microsoft.com/office/drawing/2014/main" id="{A003666B-C7B2-47B0-873A-F5BE2F8198B1}"/>
               </a:ext>
             </a:extLst>
           </p:cNvPr>
@@ -5837,7 +5837,7 @@
           <p:cNvPr id="21" name="">
             <a:extLst xmlns:a="http://schemas.openxmlformats.org/drawingml/2006/main">
               <a:ext uri="{FF2B5EF4-FFF2-40B4-BE49-F238E27FC236}">
-                <a16:creationId xmlns:a16="http://schemas.microsoft.com/office/drawing/2014/main" id="{E2754FBD-C9E4-4A01-A1A9-B94DD5E0FF24}"/>
+                <a16:creationId xmlns:a16="http://schemas.microsoft.com/office/drawing/2014/main" id="{1E0774D3-FC52-475F-9E69-E1031477B0A9}"/>
               </a:ext>
             </a:extLst>
           </p:cNvPr>
@@ -5885,7 +5885,7 @@
     </p:spTree>
     <p:extLst>
       <p:ext uri="{BB962C8B-B14F-4D97-AF65-F5344CB8AC3E}">
-        <p14:creationId xmlns:p14="http://schemas.microsoft.com/office/powerpoint/2010/main" val="760890162"/>
+        <p14:creationId xmlns:p14="http://schemas.microsoft.com/office/powerpoint/2010/main" val="860852559"/>
       </p:ext>
     </p:extLst>
   </p:cSld>
@@ -5913,10 +5913,10 @@
       </p:grpSpPr>
       <p:sp>
         <p:nvSpPr>
-          <p:cNvPr id="7" name="">
-            <a:extLst xmlns:a="http://schemas.openxmlformats.org/drawingml/2006/main">
-              <a:ext uri="{FF2B5EF4-FFF2-40B4-BE49-F238E27FC236}">
-                <a16:creationId xmlns:a16="http://schemas.microsoft.com/office/drawing/2014/main" id="{4545A6AA-F2EF-46FF-B001-E6A02BD546BF}"/>
+          <p:cNvPr id="38" name="">
+            <a:extLst xmlns:a="http://schemas.openxmlformats.org/drawingml/2006/main">
+              <a:ext uri="{FF2B5EF4-FFF2-40B4-BE49-F238E27FC236}">
+                <a16:creationId xmlns:a16="http://schemas.microsoft.com/office/drawing/2014/main" id="{103D801F-B172-416C-80B3-0A5DFFC84D71}"/>
               </a:ext>
             </a:extLst>
           </p:cNvPr>
@@ -5966,7 +5966,7 @@
           <p:cNvPr id="2" name="">
             <a:extLst xmlns:a="http://schemas.openxmlformats.org/drawingml/2006/main">
               <a:ext uri="{FF2B5EF4-FFF2-40B4-BE49-F238E27FC236}">
-                <a16:creationId xmlns:a16="http://schemas.microsoft.com/office/drawing/2014/main" id="{3E6ABC7F-1F19-436E-B7BF-5344CC3F82EF}"/>
+                <a16:creationId xmlns:a16="http://schemas.microsoft.com/office/drawing/2014/main" id="{2060BB16-2F47-4C12-BFA1-3E4D187347A2}"/>
               </a:ext>
             </a:extLst>
           </p:cNvPr>
@@ -6006,56 +6006,279 @@
                   <a:srgbClr val="102A2E"/>
                 </a:solidFill>
               </a:rPr>
-              <a:t>Completed opportunities remain useful as dated history</a:t>
-            </a:r>
-          </a:p>
-        </p:txBody>
-      </p:sp>
-      <p:pic>
-        <p:nvPicPr>
-          <p:cNvPr id="9" name=""/>
-          <p:cNvPicPr>
-            <a:picLocks xmlns:a="http://schemas.openxmlformats.org/drawingml/2006/main" noChangeAspect="1"/>
-          </p:cNvPicPr>
-          <p:nvPr/>
-        </p:nvPicPr>
-        <p:blipFill>
-          <a:blip xmlns:r="http://schemas.openxmlformats.org/officeDocument/2006/relationships" xmlns:a="http://schemas.openxmlformats.org/drawingml/2006/main" r:embed="R511ddf0d651d460e"/>
-          <a:srcRect xmlns:a="http://schemas.openxmlformats.org/drawingml/2006/main" l="0" t="27299" r="0" b="27299"/>
-          <a:stretch xmlns:a="http://schemas.openxmlformats.org/drawingml/2006/main">
-            <a:fillRect l="0" t="0" r="0" b="0"/>
-          </a:stretch>
-        </p:blipFill>
-        <p:spPr>
-          <a:xfrm xmlns:a="http://schemas.openxmlformats.org/drawingml/2006/main">
-            <a:off x="609600" y="1200150"/>
-            <a:ext cx="10972800" cy="4514850"/>
+              <a:t>Official reveal starts the highest-value monitoring window</a:t>
+            </a:r>
+          </a:p>
+        </p:txBody>
+      </p:sp>
+      <p:sp>
+        <p:nvSpPr>
+          <p:cNvPr id="3" name="">
+            <a:extLst xmlns:a="http://schemas.openxmlformats.org/drawingml/2006/main">
+              <a:ext uri="{FF2B5EF4-FFF2-40B4-BE49-F238E27FC236}">
+                <a16:creationId xmlns:a16="http://schemas.microsoft.com/office/drawing/2014/main" id="{51CADA2E-C3AD-4284-90E0-D649031DB1B4}"/>
+              </a:ext>
+            </a:extLst>
+          </p:cNvPr>
+          <p:cNvSpPr>
+            <a:spLocks xmlns:a="http://schemas.openxmlformats.org/drawingml/2006/main" noGrp="1"/>
+          </p:cNvSpPr>
+          <p:nvPr/>
+        </p:nvSpPr>
+        <p:spPr>
+          <a:xfrm xmlns:a="http://schemas.openxmlformats.org/drawingml/2006/main">
+            <a:off x="609600" y="1352550"/>
+            <a:ext cx="3143250" cy="3790950"/>
           </a:xfrm>
           <a:prstGeom xmlns:a="http://schemas.openxmlformats.org/drawingml/2006/main" prst="roundRect">
             <a:avLst>
-              <a:gd name="adj" fmla="val 2532"/>
+              <a:gd name="adj" fmla="val 3636"/>
             </a:avLst>
           </a:prstGeom>
-        </p:spPr>
-      </p:pic>
+          <a:solidFill xmlns:a="http://schemas.openxmlformats.org/drawingml/2006/main">
+            <a:srgbClr val="FFD74B"/>
+          </a:solidFill>
+          <a:ln xmlns:a="http://schemas.openxmlformats.org/drawingml/2006/main" w="0">
+            <a:noFill/>
+            <a:prstDash val="solid"/>
+          </a:ln>
+        </p:spPr>
+      </p:sp>
       <p:sp>
         <p:nvSpPr>
           <p:cNvPr id="4" name="">
             <a:extLst xmlns:a="http://schemas.openxmlformats.org/drawingml/2006/main">
               <a:ext uri="{FF2B5EF4-FFF2-40B4-BE49-F238E27FC236}">
-                <a16:creationId xmlns:a16="http://schemas.microsoft.com/office/drawing/2014/main" id="{D02C9E0A-8FC5-49E8-AA80-F99E9090F7A1}"/>
-              </a:ext>
-            </a:extLst>
-          </p:cNvPr>
-          <p:cNvSpPr>
-            <a:spLocks xmlns:a="http://schemas.openxmlformats.org/drawingml/2006/main" noGrp="1"/>
-          </p:cNvSpPr>
-          <p:nvPr/>
-        </p:nvSpPr>
-        <p:spPr>
-          <a:xfrm xmlns:a="http://schemas.openxmlformats.org/drawingml/2006/main">
-            <a:off x="0" y="6000750"/>
-            <a:ext cx="12192000" cy="857250"/>
+                <a16:creationId xmlns:a16="http://schemas.microsoft.com/office/drawing/2014/main" id="{6025ECE3-7334-4B2F-BE2E-CF4D9397BF5F}"/>
+              </a:ext>
+            </a:extLst>
+          </p:cNvPr>
+          <p:cNvSpPr>
+            <a:spLocks xmlns:a="http://schemas.openxmlformats.org/drawingml/2006/main" noGrp="1"/>
+          </p:cNvSpPr>
+          <p:nvPr/>
+        </p:nvSpPr>
+        <p:spPr>
+          <a:xfrm xmlns:a="http://schemas.openxmlformats.org/drawingml/2006/main">
+            <a:off x="876300" y="1657350"/>
+            <a:ext cx="2609850" cy="1104900"/>
+          </a:xfrm>
+          <a:prstGeom xmlns:a="http://schemas.openxmlformats.org/drawingml/2006/main" prst="rect">
+            <a:avLst/>
+          </a:prstGeom>
+          <a:noFill xmlns:a="http://schemas.openxmlformats.org/drawingml/2006/main"/>
+          <a:ln xmlns:a="http://schemas.openxmlformats.org/drawingml/2006/main" w="0">
+            <a:noFill/>
+            <a:prstDash val="solid"/>
+          </a:ln>
+        </p:spPr>
+        <p:txBody>
+          <a:bodyPr xmlns:a="http://schemas.openxmlformats.org/drawingml/2006/main" anchor="ctr"/>
+          <a:lstStyle xmlns:a="http://schemas.openxmlformats.org/drawingml/2006/main"/>
+          <a:p xmlns:a="http://schemas.openxmlformats.org/drawingml/2006/main">
+            <a:pPr algn="ctr">
+              <a:defRPr sz="7200" b="1">
+                <a:solidFill>
+                  <a:srgbClr val="102A2E"/>
+                </a:solidFill>
+              </a:defRPr>
+            </a:pPr>
+            <a:r>
+              <a:rPr sz="7200" b="1">
+                <a:solidFill>
+                  <a:srgbClr val="102A2E"/>
+                </a:solidFill>
+              </a:rPr>
+              <a:t>13</a:t>
+            </a:r>
+          </a:p>
+        </p:txBody>
+      </p:sp>
+      <p:sp>
+        <p:nvSpPr>
+          <p:cNvPr id="5" name="">
+            <a:extLst xmlns:a="http://schemas.openxmlformats.org/drawingml/2006/main">
+              <a:ext uri="{FF2B5EF4-FFF2-40B4-BE49-F238E27FC236}">
+                <a16:creationId xmlns:a16="http://schemas.microsoft.com/office/drawing/2014/main" id="{0A2CC59D-5535-4ADE-A65C-F0E741B0AE20}"/>
+              </a:ext>
+            </a:extLst>
+          </p:cNvPr>
+          <p:cNvSpPr>
+            <a:spLocks xmlns:a="http://schemas.openxmlformats.org/drawingml/2006/main" noGrp="1"/>
+          </p:cNvSpPr>
+          <p:nvPr/>
+        </p:nvSpPr>
+        <p:spPr>
+          <a:xfrm xmlns:a="http://schemas.openxmlformats.org/drawingml/2006/main">
+            <a:off x="1123950" y="2686050"/>
+            <a:ext cx="2114550" cy="400050"/>
+          </a:xfrm>
+          <a:prstGeom xmlns:a="http://schemas.openxmlformats.org/drawingml/2006/main" prst="rect">
+            <a:avLst/>
+          </a:prstGeom>
+          <a:noFill xmlns:a="http://schemas.openxmlformats.org/drawingml/2006/main"/>
+          <a:ln xmlns:a="http://schemas.openxmlformats.org/drawingml/2006/main" w="0">
+            <a:noFill/>
+            <a:prstDash val="solid"/>
+          </a:ln>
+        </p:spPr>
+        <p:txBody>
+          <a:bodyPr xmlns:a="http://schemas.openxmlformats.org/drawingml/2006/main" anchor="ctr"/>
+          <a:lstStyle xmlns:a="http://schemas.openxmlformats.org/drawingml/2006/main"/>
+          <a:p xmlns:a="http://schemas.openxmlformats.org/drawingml/2006/main">
+            <a:pPr algn="ctr">
+              <a:defRPr sz="2100" b="1">
+                <a:solidFill>
+                  <a:srgbClr val="102A2E"/>
+                </a:solidFill>
+              </a:defRPr>
+            </a:pPr>
+            <a:r>
+              <a:rPr sz="2100" b="1">
+                <a:solidFill>
+                  <a:srgbClr val="102A2E"/>
+                </a:solidFill>
+              </a:rPr>
+              <a:t>DAYS</a:t>
+            </a:r>
+          </a:p>
+        </p:txBody>
+      </p:sp>
+      <p:sp>
+        <p:nvSpPr>
+          <p:cNvPr id="6" name="">
+            <a:extLst xmlns:a="http://schemas.openxmlformats.org/drawingml/2006/main">
+              <a:ext uri="{FF2B5EF4-FFF2-40B4-BE49-F238E27FC236}">
+                <a16:creationId xmlns:a16="http://schemas.microsoft.com/office/drawing/2014/main" id="{6FDEDA9B-A60B-4DF2-9F08-2D8690F17526}"/>
+              </a:ext>
+            </a:extLst>
+          </p:cNvPr>
+          <p:cNvSpPr>
+            <a:spLocks xmlns:a="http://schemas.openxmlformats.org/drawingml/2006/main" noGrp="1"/>
+          </p:cNvSpPr>
+          <p:nvPr/>
+        </p:nvSpPr>
+        <p:spPr>
+          <a:xfrm xmlns:a="http://schemas.openxmlformats.org/drawingml/2006/main">
+            <a:off x="876300" y="3181350"/>
+            <a:ext cx="2609850" cy="514350"/>
+          </a:xfrm>
+          <a:prstGeom xmlns:a="http://schemas.openxmlformats.org/drawingml/2006/main" prst="rect">
+            <a:avLst/>
+          </a:prstGeom>
+          <a:noFill xmlns:a="http://schemas.openxmlformats.org/drawingml/2006/main"/>
+          <a:ln xmlns:a="http://schemas.openxmlformats.org/drawingml/2006/main" w="0">
+            <a:noFill/>
+            <a:prstDash val="solid"/>
+          </a:ln>
+        </p:spPr>
+        <p:txBody>
+          <a:bodyPr xmlns:a="http://schemas.openxmlformats.org/drawingml/2006/main" anchor="ctr"/>
+          <a:lstStyle xmlns:a="http://schemas.openxmlformats.org/drawingml/2006/main"/>
+          <a:p xmlns:a="http://schemas.openxmlformats.org/drawingml/2006/main">
+            <a:pPr algn="ctr">
+              <a:defRPr sz="1800" b="1">
+                <a:solidFill>
+                  <a:srgbClr val="102A2E"/>
+                </a:solidFill>
+              </a:defRPr>
+            </a:pPr>
+            <a:r>
+              <a:rPr sz="1800" b="1">
+                <a:solidFill>
+                  <a:srgbClr val="102A2E"/>
+                </a:solidFill>
+              </a:rPr>
+              <a:t>Median reveal → live</a:t>
+            </a:r>
+          </a:p>
+        </p:txBody>
+      </p:sp>
+      <p:sp>
+        <p:nvSpPr>
+          <p:cNvPr id="7" name="">
+            <a:extLst xmlns:a="http://schemas.openxmlformats.org/drawingml/2006/main">
+              <a:ext uri="{FF2B5EF4-FFF2-40B4-BE49-F238E27FC236}">
+                <a16:creationId xmlns:a16="http://schemas.microsoft.com/office/drawing/2014/main" id="{6855940B-51D3-4E99-B0B8-D8867A33797F}"/>
+              </a:ext>
+            </a:extLst>
+          </p:cNvPr>
+          <p:cNvSpPr>
+            <a:spLocks xmlns:a="http://schemas.openxmlformats.org/drawingml/2006/main" noGrp="1"/>
+          </p:cNvSpPr>
+          <p:nvPr/>
+        </p:nvSpPr>
+        <p:spPr>
+          <a:xfrm xmlns:a="http://schemas.openxmlformats.org/drawingml/2006/main">
+            <a:off x="895350" y="3886200"/>
+            <a:ext cx="2571750" cy="723900"/>
+          </a:xfrm>
+          <a:prstGeom xmlns:a="http://schemas.openxmlformats.org/drawingml/2006/main" prst="rect">
+            <a:avLst/>
+          </a:prstGeom>
+          <a:noFill xmlns:a="http://schemas.openxmlformats.org/drawingml/2006/main"/>
+          <a:ln xmlns:a="http://schemas.openxmlformats.org/drawingml/2006/main" w="0">
+            <a:noFill/>
+            <a:prstDash val="solid"/>
+          </a:ln>
+        </p:spPr>
+        <p:txBody>
+          <a:bodyPr xmlns:a="http://schemas.openxmlformats.org/drawingml/2006/main" anchor="ctr"/>
+          <a:lstStyle xmlns:a="http://schemas.openxmlformats.org/drawingml/2006/main"/>
+          <a:p xmlns:a="http://schemas.openxmlformats.org/drawingml/2006/main">
+            <a:pPr algn="ctr">
+              <a:defRPr sz="1425">
+                <a:solidFill>
+                  <a:srgbClr val="365157"/>
+                </a:solidFill>
+              </a:defRPr>
+            </a:pPr>
+            <a:r>
+              <a:rPr sz="1425">
+                <a:solidFill>
+                  <a:srgbClr val="365157"/>
+                </a:solidFill>
+              </a:rPr>
+              <a:t>7 recent product waves</a:t>
+            </a:r>
+          </a:p>
+          <a:p xmlns:a="http://schemas.openxmlformats.org/drawingml/2006/main">
+            <a:pPr algn="ctr">
+              <a:defRPr sz="1425">
+                <a:solidFill>
+                  <a:srgbClr val="365157"/>
+                </a:solidFill>
+              </a:defRPr>
+            </a:pPr>
+            <a:r>
+              <a:rPr sz="1425">
+                <a:solidFill>
+                  <a:srgbClr val="365157"/>
+                </a:solidFill>
+              </a:rPr>
+              <a:t>Observed range: 0–41 days</a:t>
+            </a:r>
+          </a:p>
+        </p:txBody>
+      </p:sp>
+      <p:sp>
+        <p:nvSpPr>
+          <p:cNvPr id="8" name="">
+            <a:extLst xmlns:a="http://schemas.openxmlformats.org/drawingml/2006/main">
+              <a:ext uri="{FF2B5EF4-FFF2-40B4-BE49-F238E27FC236}">
+                <a16:creationId xmlns:a16="http://schemas.microsoft.com/office/drawing/2014/main" id="{45400690-5A6A-4B63-AA37-BD9A7EC516C2}"/>
+              </a:ext>
+            </a:extLst>
+          </p:cNvPr>
+          <p:cNvSpPr>
+            <a:spLocks xmlns:a="http://schemas.openxmlformats.org/drawingml/2006/main" noGrp="1"/>
+          </p:cNvSpPr>
+          <p:nvPr/>
+        </p:nvSpPr>
+        <p:spPr>
+          <a:xfrm xmlns:a="http://schemas.openxmlformats.org/drawingml/2006/main">
+            <a:off x="4457700" y="3181350"/>
+            <a:ext cx="6667500" cy="38100"/>
           </a:xfrm>
           <a:prstGeom xmlns:a="http://schemas.openxmlformats.org/drawingml/2006/main" prst="rect">
             <a:avLst/>
@@ -6073,22 +6296,437 @@
       </p:sp>
       <p:sp>
         <p:nvSpPr>
-          <p:cNvPr id="5" name="">
-            <a:extLst xmlns:a="http://schemas.openxmlformats.org/drawingml/2006/main">
-              <a:ext uri="{FF2B5EF4-FFF2-40B4-BE49-F238E27FC236}">
-                <a16:creationId xmlns:a16="http://schemas.microsoft.com/office/drawing/2014/main" id="{CB69A7B6-1BAE-4E8A-BA8D-6D9ED1A71D20}"/>
-              </a:ext>
-            </a:extLst>
-          </p:cNvPr>
-          <p:cNvSpPr>
-            <a:spLocks xmlns:a="http://schemas.openxmlformats.org/drawingml/2006/main" noGrp="1"/>
-          </p:cNvSpPr>
-          <p:nvPr/>
-        </p:nvSpPr>
-        <p:spPr>
-          <a:xfrm xmlns:a="http://schemas.openxmlformats.org/drawingml/2006/main">
-            <a:off x="495300" y="6229350"/>
-            <a:ext cx="323850" cy="323850"/>
+          <p:cNvPr id="9" name="">
+            <a:extLst xmlns:a="http://schemas.openxmlformats.org/drawingml/2006/main">
+              <a:ext uri="{FF2B5EF4-FFF2-40B4-BE49-F238E27FC236}">
+                <a16:creationId xmlns:a16="http://schemas.microsoft.com/office/drawing/2014/main" id="{C1953B89-14A2-4C62-BBA2-C6A2F724203E}"/>
+              </a:ext>
+            </a:extLst>
+          </p:cNvPr>
+          <p:cNvSpPr>
+            <a:spLocks xmlns:a="http://schemas.openxmlformats.org/drawingml/2006/main" noGrp="1"/>
+          </p:cNvSpPr>
+          <p:nvPr/>
+        </p:nvSpPr>
+        <p:spPr>
+          <a:xfrm xmlns:a="http://schemas.openxmlformats.org/drawingml/2006/main">
+            <a:off x="4457700" y="3105150"/>
+            <a:ext cx="19050" cy="190500"/>
+          </a:xfrm>
+          <a:prstGeom xmlns:a="http://schemas.openxmlformats.org/drawingml/2006/main" prst="rect">
+            <a:avLst/>
+          </a:prstGeom>
+          <a:solidFill xmlns:a="http://schemas.openxmlformats.org/drawingml/2006/main">
+            <a:srgbClr val="365157"/>
+          </a:solidFill>
+          <a:ln xmlns:a="http://schemas.openxmlformats.org/drawingml/2006/main" w="0">
+            <a:solidFill>
+              <a:srgbClr val="365157"/>
+            </a:solidFill>
+            <a:prstDash val="solid"/>
+          </a:ln>
+        </p:spPr>
+      </p:sp>
+      <p:sp>
+        <p:nvSpPr>
+          <p:cNvPr id="10" name="">
+            <a:extLst xmlns:a="http://schemas.openxmlformats.org/drawingml/2006/main">
+              <a:ext uri="{FF2B5EF4-FFF2-40B4-BE49-F238E27FC236}">
+                <a16:creationId xmlns:a16="http://schemas.microsoft.com/office/drawing/2014/main" id="{55B78CAF-3336-4D2B-8457-104D2D53EEE8}"/>
+              </a:ext>
+            </a:extLst>
+          </p:cNvPr>
+          <p:cNvSpPr>
+            <a:spLocks xmlns:a="http://schemas.openxmlformats.org/drawingml/2006/main" noGrp="1"/>
+          </p:cNvSpPr>
+          <p:nvPr/>
+        </p:nvSpPr>
+        <p:spPr>
+          <a:xfrm xmlns:a="http://schemas.openxmlformats.org/drawingml/2006/main">
+            <a:off x="4286250" y="3352800"/>
+            <a:ext cx="361950" cy="228600"/>
+          </a:xfrm>
+          <a:prstGeom xmlns:a="http://schemas.openxmlformats.org/drawingml/2006/main" prst="rect">
+            <a:avLst/>
+          </a:prstGeom>
+          <a:noFill xmlns:a="http://schemas.openxmlformats.org/drawingml/2006/main"/>
+          <a:ln xmlns:a="http://schemas.openxmlformats.org/drawingml/2006/main" w="0">
+            <a:noFill/>
+            <a:prstDash val="solid"/>
+          </a:ln>
+        </p:spPr>
+        <p:txBody>
+          <a:bodyPr xmlns:a="http://schemas.openxmlformats.org/drawingml/2006/main" anchor="ctr"/>
+          <a:lstStyle xmlns:a="http://schemas.openxmlformats.org/drawingml/2006/main"/>
+          <a:p xmlns:a="http://schemas.openxmlformats.org/drawingml/2006/main">
+            <a:pPr algn="ctr">
+              <a:defRPr sz="1050">
+                <a:solidFill>
+                  <a:srgbClr val="365157"/>
+                </a:solidFill>
+              </a:defRPr>
+            </a:pPr>
+            <a:r>
+              <a:rPr sz="1050">
+                <a:solidFill>
+                  <a:srgbClr val="365157"/>
+                </a:solidFill>
+              </a:rPr>
+              <a:t>0</a:t>
+            </a:r>
+          </a:p>
+        </p:txBody>
+      </p:sp>
+      <p:sp>
+        <p:nvSpPr>
+          <p:cNvPr id="11" name="">
+            <a:extLst xmlns:a="http://schemas.openxmlformats.org/drawingml/2006/main">
+              <a:ext uri="{FF2B5EF4-FFF2-40B4-BE49-F238E27FC236}">
+                <a16:creationId xmlns:a16="http://schemas.microsoft.com/office/drawing/2014/main" id="{BF179422-FC8B-41B2-A720-1195ED8A078D}"/>
+              </a:ext>
+            </a:extLst>
+          </p:cNvPr>
+          <p:cNvSpPr>
+            <a:spLocks xmlns:a="http://schemas.openxmlformats.org/drawingml/2006/main" noGrp="1"/>
+          </p:cNvSpPr>
+          <p:nvPr/>
+        </p:nvSpPr>
+        <p:spPr>
+          <a:xfrm xmlns:a="http://schemas.openxmlformats.org/drawingml/2006/main">
+            <a:off x="6083920" y="3105150"/>
+            <a:ext cx="19050" cy="190500"/>
+          </a:xfrm>
+          <a:prstGeom xmlns:a="http://schemas.openxmlformats.org/drawingml/2006/main" prst="rect">
+            <a:avLst/>
+          </a:prstGeom>
+          <a:solidFill xmlns:a="http://schemas.openxmlformats.org/drawingml/2006/main">
+            <a:srgbClr val="365157"/>
+          </a:solidFill>
+          <a:ln xmlns:a="http://schemas.openxmlformats.org/drawingml/2006/main" w="0">
+            <a:solidFill>
+              <a:srgbClr val="365157"/>
+            </a:solidFill>
+            <a:prstDash val="solid"/>
+          </a:ln>
+        </p:spPr>
+      </p:sp>
+      <p:sp>
+        <p:nvSpPr>
+          <p:cNvPr id="12" name="">
+            <a:extLst xmlns:a="http://schemas.openxmlformats.org/drawingml/2006/main">
+              <a:ext uri="{FF2B5EF4-FFF2-40B4-BE49-F238E27FC236}">
+                <a16:creationId xmlns:a16="http://schemas.microsoft.com/office/drawing/2014/main" id="{F9F07681-E36E-4C01-90B7-E328D8A114D0}"/>
+              </a:ext>
+            </a:extLst>
+          </p:cNvPr>
+          <p:cNvSpPr>
+            <a:spLocks xmlns:a="http://schemas.openxmlformats.org/drawingml/2006/main" noGrp="1"/>
+          </p:cNvSpPr>
+          <p:nvPr/>
+        </p:nvSpPr>
+        <p:spPr>
+          <a:xfrm xmlns:a="http://schemas.openxmlformats.org/drawingml/2006/main">
+            <a:off x="5912470" y="3352800"/>
+            <a:ext cx="361950" cy="228600"/>
+          </a:xfrm>
+          <a:prstGeom xmlns:a="http://schemas.openxmlformats.org/drawingml/2006/main" prst="rect">
+            <a:avLst/>
+          </a:prstGeom>
+          <a:noFill xmlns:a="http://schemas.openxmlformats.org/drawingml/2006/main"/>
+          <a:ln xmlns:a="http://schemas.openxmlformats.org/drawingml/2006/main" w="0">
+            <a:noFill/>
+            <a:prstDash val="solid"/>
+          </a:ln>
+        </p:spPr>
+        <p:txBody>
+          <a:bodyPr xmlns:a="http://schemas.openxmlformats.org/drawingml/2006/main" anchor="ctr"/>
+          <a:lstStyle xmlns:a="http://schemas.openxmlformats.org/drawingml/2006/main"/>
+          <a:p xmlns:a="http://schemas.openxmlformats.org/drawingml/2006/main">
+            <a:pPr algn="ctr">
+              <a:defRPr sz="1050">
+                <a:solidFill>
+                  <a:srgbClr val="365157"/>
+                </a:solidFill>
+              </a:defRPr>
+            </a:pPr>
+            <a:r>
+              <a:rPr sz="1050">
+                <a:solidFill>
+                  <a:srgbClr val="365157"/>
+                </a:solidFill>
+              </a:rPr>
+              <a:t>10</a:t>
+            </a:r>
+          </a:p>
+        </p:txBody>
+      </p:sp>
+      <p:sp>
+        <p:nvSpPr>
+          <p:cNvPr id="13" name="">
+            <a:extLst xmlns:a="http://schemas.openxmlformats.org/drawingml/2006/main">
+              <a:ext uri="{FF2B5EF4-FFF2-40B4-BE49-F238E27FC236}">
+                <a16:creationId xmlns:a16="http://schemas.microsoft.com/office/drawing/2014/main" id="{8B49EF5B-E51A-4F0A-B7D8-B7F7ADF1901E}"/>
+              </a:ext>
+            </a:extLst>
+          </p:cNvPr>
+          <p:cNvSpPr>
+            <a:spLocks xmlns:a="http://schemas.openxmlformats.org/drawingml/2006/main" noGrp="1"/>
+          </p:cNvSpPr>
+          <p:nvPr/>
+        </p:nvSpPr>
+        <p:spPr>
+          <a:xfrm xmlns:a="http://schemas.openxmlformats.org/drawingml/2006/main">
+            <a:off x="7710139" y="3105150"/>
+            <a:ext cx="19050" cy="190500"/>
+          </a:xfrm>
+          <a:prstGeom xmlns:a="http://schemas.openxmlformats.org/drawingml/2006/main" prst="rect">
+            <a:avLst/>
+          </a:prstGeom>
+          <a:solidFill xmlns:a="http://schemas.openxmlformats.org/drawingml/2006/main">
+            <a:srgbClr val="365157"/>
+          </a:solidFill>
+          <a:ln xmlns:a="http://schemas.openxmlformats.org/drawingml/2006/main" w="0">
+            <a:solidFill>
+              <a:srgbClr val="365157"/>
+            </a:solidFill>
+            <a:prstDash val="solid"/>
+          </a:ln>
+        </p:spPr>
+      </p:sp>
+      <p:sp>
+        <p:nvSpPr>
+          <p:cNvPr id="14" name="">
+            <a:extLst xmlns:a="http://schemas.openxmlformats.org/drawingml/2006/main">
+              <a:ext uri="{FF2B5EF4-FFF2-40B4-BE49-F238E27FC236}">
+                <a16:creationId xmlns:a16="http://schemas.microsoft.com/office/drawing/2014/main" id="{DA77F10E-F2EC-40A7-ABC1-CBA752C6B582}"/>
+              </a:ext>
+            </a:extLst>
+          </p:cNvPr>
+          <p:cNvSpPr>
+            <a:spLocks xmlns:a="http://schemas.openxmlformats.org/drawingml/2006/main" noGrp="1"/>
+          </p:cNvSpPr>
+          <p:nvPr/>
+        </p:nvSpPr>
+        <p:spPr>
+          <a:xfrm xmlns:a="http://schemas.openxmlformats.org/drawingml/2006/main">
+            <a:off x="7538689" y="3352800"/>
+            <a:ext cx="361950" cy="228600"/>
+          </a:xfrm>
+          <a:prstGeom xmlns:a="http://schemas.openxmlformats.org/drawingml/2006/main" prst="rect">
+            <a:avLst/>
+          </a:prstGeom>
+          <a:noFill xmlns:a="http://schemas.openxmlformats.org/drawingml/2006/main"/>
+          <a:ln xmlns:a="http://schemas.openxmlformats.org/drawingml/2006/main" w="0">
+            <a:noFill/>
+            <a:prstDash val="solid"/>
+          </a:ln>
+        </p:spPr>
+        <p:txBody>
+          <a:bodyPr xmlns:a="http://schemas.openxmlformats.org/drawingml/2006/main" anchor="ctr"/>
+          <a:lstStyle xmlns:a="http://schemas.openxmlformats.org/drawingml/2006/main"/>
+          <a:p xmlns:a="http://schemas.openxmlformats.org/drawingml/2006/main">
+            <a:pPr algn="ctr">
+              <a:defRPr sz="1050">
+                <a:solidFill>
+                  <a:srgbClr val="365157"/>
+                </a:solidFill>
+              </a:defRPr>
+            </a:pPr>
+            <a:r>
+              <a:rPr sz="1050">
+                <a:solidFill>
+                  <a:srgbClr val="365157"/>
+                </a:solidFill>
+              </a:rPr>
+              <a:t>20</a:t>
+            </a:r>
+          </a:p>
+        </p:txBody>
+      </p:sp>
+      <p:sp>
+        <p:nvSpPr>
+          <p:cNvPr id="15" name="">
+            <a:extLst xmlns:a="http://schemas.openxmlformats.org/drawingml/2006/main">
+              <a:ext uri="{FF2B5EF4-FFF2-40B4-BE49-F238E27FC236}">
+                <a16:creationId xmlns:a16="http://schemas.microsoft.com/office/drawing/2014/main" id="{C5E4D59E-6DEE-4C80-9427-B23356D2CD60}"/>
+              </a:ext>
+            </a:extLst>
+          </p:cNvPr>
+          <p:cNvSpPr>
+            <a:spLocks xmlns:a="http://schemas.openxmlformats.org/drawingml/2006/main" noGrp="1"/>
+          </p:cNvSpPr>
+          <p:nvPr/>
+        </p:nvSpPr>
+        <p:spPr>
+          <a:xfrm xmlns:a="http://schemas.openxmlformats.org/drawingml/2006/main">
+            <a:off x="9336359" y="3105150"/>
+            <a:ext cx="19050" cy="190500"/>
+          </a:xfrm>
+          <a:prstGeom xmlns:a="http://schemas.openxmlformats.org/drawingml/2006/main" prst="rect">
+            <a:avLst/>
+          </a:prstGeom>
+          <a:solidFill xmlns:a="http://schemas.openxmlformats.org/drawingml/2006/main">
+            <a:srgbClr val="365157"/>
+          </a:solidFill>
+          <a:ln xmlns:a="http://schemas.openxmlformats.org/drawingml/2006/main" w="0">
+            <a:solidFill>
+              <a:srgbClr val="365157"/>
+            </a:solidFill>
+            <a:prstDash val="solid"/>
+          </a:ln>
+        </p:spPr>
+      </p:sp>
+      <p:sp>
+        <p:nvSpPr>
+          <p:cNvPr id="16" name="">
+            <a:extLst xmlns:a="http://schemas.openxmlformats.org/drawingml/2006/main">
+              <a:ext uri="{FF2B5EF4-FFF2-40B4-BE49-F238E27FC236}">
+                <a16:creationId xmlns:a16="http://schemas.microsoft.com/office/drawing/2014/main" id="{3175D2EB-346B-4790-8EDE-5F6AB9033961}"/>
+              </a:ext>
+            </a:extLst>
+          </p:cNvPr>
+          <p:cNvSpPr>
+            <a:spLocks xmlns:a="http://schemas.openxmlformats.org/drawingml/2006/main" noGrp="1"/>
+          </p:cNvSpPr>
+          <p:nvPr/>
+        </p:nvSpPr>
+        <p:spPr>
+          <a:xfrm xmlns:a="http://schemas.openxmlformats.org/drawingml/2006/main">
+            <a:off x="9164909" y="3352800"/>
+            <a:ext cx="361950" cy="228600"/>
+          </a:xfrm>
+          <a:prstGeom xmlns:a="http://schemas.openxmlformats.org/drawingml/2006/main" prst="rect">
+            <a:avLst/>
+          </a:prstGeom>
+          <a:noFill xmlns:a="http://schemas.openxmlformats.org/drawingml/2006/main"/>
+          <a:ln xmlns:a="http://schemas.openxmlformats.org/drawingml/2006/main" w="0">
+            <a:noFill/>
+            <a:prstDash val="solid"/>
+          </a:ln>
+        </p:spPr>
+        <p:txBody>
+          <a:bodyPr xmlns:a="http://schemas.openxmlformats.org/drawingml/2006/main" anchor="ctr"/>
+          <a:lstStyle xmlns:a="http://schemas.openxmlformats.org/drawingml/2006/main"/>
+          <a:p xmlns:a="http://schemas.openxmlformats.org/drawingml/2006/main">
+            <a:pPr algn="ctr">
+              <a:defRPr sz="1050">
+                <a:solidFill>
+                  <a:srgbClr val="365157"/>
+                </a:solidFill>
+              </a:defRPr>
+            </a:pPr>
+            <a:r>
+              <a:rPr sz="1050">
+                <a:solidFill>
+                  <a:srgbClr val="365157"/>
+                </a:solidFill>
+              </a:rPr>
+              <a:t>30</a:t>
+            </a:r>
+          </a:p>
+        </p:txBody>
+      </p:sp>
+      <p:sp>
+        <p:nvSpPr>
+          <p:cNvPr id="17" name="">
+            <a:extLst xmlns:a="http://schemas.openxmlformats.org/drawingml/2006/main">
+              <a:ext uri="{FF2B5EF4-FFF2-40B4-BE49-F238E27FC236}">
+                <a16:creationId xmlns:a16="http://schemas.microsoft.com/office/drawing/2014/main" id="{0962C9DC-1733-4E0B-873C-A3822D95F32C}"/>
+              </a:ext>
+            </a:extLst>
+          </p:cNvPr>
+          <p:cNvSpPr>
+            <a:spLocks xmlns:a="http://schemas.openxmlformats.org/drawingml/2006/main" noGrp="1"/>
+          </p:cNvSpPr>
+          <p:nvPr/>
+        </p:nvSpPr>
+        <p:spPr>
+          <a:xfrm xmlns:a="http://schemas.openxmlformats.org/drawingml/2006/main">
+            <a:off x="11125200" y="3105150"/>
+            <a:ext cx="19050" cy="190500"/>
+          </a:xfrm>
+          <a:prstGeom xmlns:a="http://schemas.openxmlformats.org/drawingml/2006/main" prst="rect">
+            <a:avLst/>
+          </a:prstGeom>
+          <a:solidFill xmlns:a="http://schemas.openxmlformats.org/drawingml/2006/main">
+            <a:srgbClr val="365157"/>
+          </a:solidFill>
+          <a:ln xmlns:a="http://schemas.openxmlformats.org/drawingml/2006/main" w="0">
+            <a:solidFill>
+              <a:srgbClr val="365157"/>
+            </a:solidFill>
+            <a:prstDash val="solid"/>
+          </a:ln>
+        </p:spPr>
+      </p:sp>
+      <p:sp>
+        <p:nvSpPr>
+          <p:cNvPr id="18" name="">
+            <a:extLst xmlns:a="http://schemas.openxmlformats.org/drawingml/2006/main">
+              <a:ext uri="{FF2B5EF4-FFF2-40B4-BE49-F238E27FC236}">
+                <a16:creationId xmlns:a16="http://schemas.microsoft.com/office/drawing/2014/main" id="{05ED37CA-0B49-4D8D-B8EA-503CC34BA57D}"/>
+              </a:ext>
+            </a:extLst>
+          </p:cNvPr>
+          <p:cNvSpPr>
+            <a:spLocks xmlns:a="http://schemas.openxmlformats.org/drawingml/2006/main" noGrp="1"/>
+          </p:cNvSpPr>
+          <p:nvPr/>
+        </p:nvSpPr>
+        <p:spPr>
+          <a:xfrm xmlns:a="http://schemas.openxmlformats.org/drawingml/2006/main">
+            <a:off x="10953750" y="3352800"/>
+            <a:ext cx="361950" cy="228600"/>
+          </a:xfrm>
+          <a:prstGeom xmlns:a="http://schemas.openxmlformats.org/drawingml/2006/main" prst="rect">
+            <a:avLst/>
+          </a:prstGeom>
+          <a:noFill xmlns:a="http://schemas.openxmlformats.org/drawingml/2006/main"/>
+          <a:ln xmlns:a="http://schemas.openxmlformats.org/drawingml/2006/main" w="0">
+            <a:noFill/>
+            <a:prstDash val="solid"/>
+          </a:ln>
+        </p:spPr>
+        <p:txBody>
+          <a:bodyPr xmlns:a="http://schemas.openxmlformats.org/drawingml/2006/main" anchor="ctr"/>
+          <a:lstStyle xmlns:a="http://schemas.openxmlformats.org/drawingml/2006/main"/>
+          <a:p xmlns:a="http://schemas.openxmlformats.org/drawingml/2006/main">
+            <a:pPr algn="ctr">
+              <a:defRPr sz="1050">
+                <a:solidFill>
+                  <a:srgbClr val="365157"/>
+                </a:solidFill>
+              </a:defRPr>
+            </a:pPr>
+            <a:r>
+              <a:rPr sz="1050">
+                <a:solidFill>
+                  <a:srgbClr val="365157"/>
+                </a:solidFill>
+              </a:rPr>
+              <a:t>41</a:t>
+            </a:r>
+          </a:p>
+        </p:txBody>
+      </p:sp>
+      <p:sp>
+        <p:nvSpPr>
+          <p:cNvPr id="19" name="">
+            <a:extLst xmlns:a="http://schemas.openxmlformats.org/drawingml/2006/main">
+              <a:ext uri="{FF2B5EF4-FFF2-40B4-BE49-F238E27FC236}">
+                <a16:creationId xmlns:a16="http://schemas.microsoft.com/office/drawing/2014/main" id="{D7B34DD2-DE00-4B59-BE58-2352C2DD4562}"/>
+              </a:ext>
+            </a:extLst>
+          </p:cNvPr>
+          <p:cNvSpPr>
+            <a:spLocks xmlns:a="http://schemas.openxmlformats.org/drawingml/2006/main" noGrp="1"/>
+          </p:cNvSpPr>
+          <p:nvPr/>
+        </p:nvSpPr>
+        <p:spPr>
+          <a:xfrm xmlns:a="http://schemas.openxmlformats.org/drawingml/2006/main">
+            <a:off x="4381500" y="3124200"/>
+            <a:ext cx="171450" cy="171450"/>
           </a:xfrm>
           <a:prstGeom xmlns:a="http://schemas.openxmlformats.org/drawingml/2006/main" prst="ellipse">
             <a:avLst/>
@@ -6096,6 +6734,720 @@
           <a:solidFill xmlns:a="http://schemas.openxmlformats.org/drawingml/2006/main">
             <a:srgbClr val="FFD74B"/>
           </a:solidFill>
+          <a:ln xmlns:a="http://schemas.openxmlformats.org/drawingml/2006/main" w="19050">
+            <a:solidFill>
+              <a:srgbClr val="102A2E"/>
+            </a:solidFill>
+            <a:prstDash val="solid"/>
+          </a:ln>
+        </p:spPr>
+      </p:sp>
+      <p:sp>
+        <p:nvSpPr>
+          <p:cNvPr id="20" name="">
+            <a:extLst xmlns:a="http://schemas.openxmlformats.org/drawingml/2006/main">
+              <a:ext uri="{FF2B5EF4-FFF2-40B4-BE49-F238E27FC236}">
+                <a16:creationId xmlns:a16="http://schemas.microsoft.com/office/drawing/2014/main" id="{AEBFCD20-4D43-4834-BB67-85A34B2F6E2A}"/>
+              </a:ext>
+            </a:extLst>
+          </p:cNvPr>
+          <p:cNvSpPr>
+            <a:spLocks xmlns:a="http://schemas.openxmlformats.org/drawingml/2006/main" noGrp="1"/>
+          </p:cNvSpPr>
+          <p:nvPr/>
+        </p:nvSpPr>
+        <p:spPr>
+          <a:xfrm xmlns:a="http://schemas.openxmlformats.org/drawingml/2006/main">
+            <a:off x="4057650" y="2152650"/>
+            <a:ext cx="1524000" cy="285750"/>
+          </a:xfrm>
+          <a:prstGeom xmlns:a="http://schemas.openxmlformats.org/drawingml/2006/main" prst="rect">
+            <a:avLst/>
+          </a:prstGeom>
+          <a:noFill xmlns:a="http://schemas.openxmlformats.org/drawingml/2006/main"/>
+          <a:ln xmlns:a="http://schemas.openxmlformats.org/drawingml/2006/main" w="0">
+            <a:noFill/>
+            <a:prstDash val="solid"/>
+          </a:ln>
+        </p:spPr>
+        <p:txBody>
+          <a:bodyPr xmlns:a="http://schemas.openxmlformats.org/drawingml/2006/main" anchor="ctr"/>
+          <a:lstStyle xmlns:a="http://schemas.openxmlformats.org/drawingml/2006/main"/>
+          <a:p xmlns:a="http://schemas.openxmlformats.org/drawingml/2006/main">
+            <a:pPr algn="ctr">
+              <a:defRPr sz="1125" b="1">
+                <a:solidFill>
+                  <a:srgbClr val="102A2E"/>
+                </a:solidFill>
+              </a:defRPr>
+            </a:pPr>
+            <a:r>
+              <a:rPr sz="1125" b="1">
+                <a:solidFill>
+                  <a:srgbClr val="102A2E"/>
+                </a:solidFill>
+              </a:rPr>
+              <a:t>Perfect Order · 0d</a:t>
+            </a:r>
+          </a:p>
+        </p:txBody>
+      </p:sp>
+      <p:sp>
+        <p:nvSpPr>
+          <p:cNvPr id="21" name="">
+            <a:extLst xmlns:a="http://schemas.openxmlformats.org/drawingml/2006/main">
+              <a:ext uri="{FF2B5EF4-FFF2-40B4-BE49-F238E27FC236}">
+                <a16:creationId xmlns:a16="http://schemas.microsoft.com/office/drawing/2014/main" id="{AA65DCE8-A123-4D5D-9D73-0C4EC7424D9A}"/>
+              </a:ext>
+            </a:extLst>
+          </p:cNvPr>
+          <p:cNvSpPr>
+            <a:spLocks xmlns:a="http://schemas.openxmlformats.org/drawingml/2006/main" noGrp="1"/>
+          </p:cNvSpPr>
+          <p:nvPr/>
+        </p:nvSpPr>
+        <p:spPr>
+          <a:xfrm xmlns:a="http://schemas.openxmlformats.org/drawingml/2006/main">
+            <a:off x="5194610" y="3124200"/>
+            <a:ext cx="171450" cy="171450"/>
+          </a:xfrm>
+          <a:prstGeom xmlns:a="http://schemas.openxmlformats.org/drawingml/2006/main" prst="ellipse">
+            <a:avLst/>
+          </a:prstGeom>
+          <a:solidFill xmlns:a="http://schemas.openxmlformats.org/drawingml/2006/main">
+            <a:srgbClr val="FFD74B"/>
+          </a:solidFill>
+          <a:ln xmlns:a="http://schemas.openxmlformats.org/drawingml/2006/main" w="19050">
+            <a:solidFill>
+              <a:srgbClr val="102A2E"/>
+            </a:solidFill>
+            <a:prstDash val="solid"/>
+          </a:ln>
+        </p:spPr>
+      </p:sp>
+      <p:sp>
+        <p:nvSpPr>
+          <p:cNvPr id="22" name="">
+            <a:extLst xmlns:a="http://schemas.openxmlformats.org/drawingml/2006/main">
+              <a:ext uri="{FF2B5EF4-FFF2-40B4-BE49-F238E27FC236}">
+                <a16:creationId xmlns:a16="http://schemas.microsoft.com/office/drawing/2014/main" id="{8C43CE51-25A0-4565-A7A1-A4D4545BBAFE}"/>
+              </a:ext>
+            </a:extLst>
+          </p:cNvPr>
+          <p:cNvSpPr>
+            <a:spLocks xmlns:a="http://schemas.openxmlformats.org/drawingml/2006/main" noGrp="1"/>
+          </p:cNvSpPr>
+          <p:nvPr/>
+        </p:nvSpPr>
+        <p:spPr>
+          <a:xfrm xmlns:a="http://schemas.openxmlformats.org/drawingml/2006/main">
+            <a:off x="4527860" y="2571750"/>
+            <a:ext cx="1524000" cy="285750"/>
+          </a:xfrm>
+          <a:prstGeom xmlns:a="http://schemas.openxmlformats.org/drawingml/2006/main" prst="rect">
+            <a:avLst/>
+          </a:prstGeom>
+          <a:noFill xmlns:a="http://schemas.openxmlformats.org/drawingml/2006/main"/>
+          <a:ln xmlns:a="http://schemas.openxmlformats.org/drawingml/2006/main" w="0">
+            <a:noFill/>
+            <a:prstDash val="solid"/>
+          </a:ln>
+        </p:spPr>
+        <p:txBody>
+          <a:bodyPr xmlns:a="http://schemas.openxmlformats.org/drawingml/2006/main" anchor="ctr"/>
+          <a:lstStyle xmlns:a="http://schemas.openxmlformats.org/drawingml/2006/main"/>
+          <a:p xmlns:a="http://schemas.openxmlformats.org/drawingml/2006/main">
+            <a:pPr algn="ctr">
+              <a:defRPr sz="1125" b="1">
+                <a:solidFill>
+                  <a:srgbClr val="102A2E"/>
+                </a:solidFill>
+              </a:defRPr>
+            </a:pPr>
+            <a:r>
+              <a:rPr sz="1125" b="1">
+                <a:solidFill>
+                  <a:srgbClr val="102A2E"/>
+                </a:solidFill>
+              </a:rPr>
+              <a:t>Mega Evolution · 5d</a:t>
+            </a:r>
+          </a:p>
+        </p:txBody>
+      </p:sp>
+      <p:sp>
+        <p:nvSpPr>
+          <p:cNvPr id="23" name="">
+            <a:extLst xmlns:a="http://schemas.openxmlformats.org/drawingml/2006/main">
+              <a:ext uri="{FF2B5EF4-FFF2-40B4-BE49-F238E27FC236}">
+                <a16:creationId xmlns:a16="http://schemas.microsoft.com/office/drawing/2014/main" id="{8EC3ABC8-E50F-4080-81AB-EA526C43E87E}"/>
+              </a:ext>
+            </a:extLst>
+          </p:cNvPr>
+          <p:cNvSpPr>
+            <a:spLocks xmlns:a="http://schemas.openxmlformats.org/drawingml/2006/main" noGrp="1"/>
+          </p:cNvSpPr>
+          <p:nvPr/>
+        </p:nvSpPr>
+        <p:spPr>
+          <a:xfrm xmlns:a="http://schemas.openxmlformats.org/drawingml/2006/main">
+            <a:off x="5194610" y="3124200"/>
+            <a:ext cx="171450" cy="171450"/>
+          </a:xfrm>
+          <a:prstGeom xmlns:a="http://schemas.openxmlformats.org/drawingml/2006/main" prst="ellipse">
+            <a:avLst/>
+          </a:prstGeom>
+          <a:solidFill xmlns:a="http://schemas.openxmlformats.org/drawingml/2006/main">
+            <a:srgbClr val="FFD74B"/>
+          </a:solidFill>
+          <a:ln xmlns:a="http://schemas.openxmlformats.org/drawingml/2006/main" w="19050">
+            <a:solidFill>
+              <a:srgbClr val="102A2E"/>
+            </a:solidFill>
+            <a:prstDash val="solid"/>
+          </a:ln>
+        </p:spPr>
+      </p:sp>
+      <p:sp>
+        <p:nvSpPr>
+          <p:cNvPr id="24" name="">
+            <a:extLst xmlns:a="http://schemas.openxmlformats.org/drawingml/2006/main">
+              <a:ext uri="{FF2B5EF4-FFF2-40B4-BE49-F238E27FC236}">
+                <a16:creationId xmlns:a16="http://schemas.microsoft.com/office/drawing/2014/main" id="{47FA849D-E87B-429A-B509-24A5E502D2A8}"/>
+              </a:ext>
+            </a:extLst>
+          </p:cNvPr>
+          <p:cNvSpPr>
+            <a:spLocks xmlns:a="http://schemas.openxmlformats.org/drawingml/2006/main" noGrp="1"/>
+          </p:cNvSpPr>
+          <p:nvPr/>
+        </p:nvSpPr>
+        <p:spPr>
+          <a:xfrm xmlns:a="http://schemas.openxmlformats.org/drawingml/2006/main">
+            <a:off x="4527860" y="3810000"/>
+            <a:ext cx="1524000" cy="285750"/>
+          </a:xfrm>
+          <a:prstGeom xmlns:a="http://schemas.openxmlformats.org/drawingml/2006/main" prst="rect">
+            <a:avLst/>
+          </a:prstGeom>
+          <a:noFill xmlns:a="http://schemas.openxmlformats.org/drawingml/2006/main"/>
+          <a:ln xmlns:a="http://schemas.openxmlformats.org/drawingml/2006/main" w="0">
+            <a:noFill/>
+            <a:prstDash val="solid"/>
+          </a:ln>
+        </p:spPr>
+        <p:txBody>
+          <a:bodyPr xmlns:a="http://schemas.openxmlformats.org/drawingml/2006/main" anchor="ctr"/>
+          <a:lstStyle xmlns:a="http://schemas.openxmlformats.org/drawingml/2006/main"/>
+          <a:p xmlns:a="http://schemas.openxmlformats.org/drawingml/2006/main">
+            <a:pPr algn="ctr">
+              <a:defRPr sz="1125" b="1">
+                <a:solidFill>
+                  <a:srgbClr val="102A2E"/>
+                </a:solidFill>
+              </a:defRPr>
+            </a:pPr>
+            <a:r>
+              <a:rPr sz="1125" b="1">
+                <a:solidFill>
+                  <a:srgbClr val="102A2E"/>
+                </a:solidFill>
+              </a:rPr>
+              <a:t>Ascended Heroes · 5d</a:t>
+            </a:r>
+          </a:p>
+        </p:txBody>
+      </p:sp>
+      <p:sp>
+        <p:nvSpPr>
+          <p:cNvPr id="25" name="">
+            <a:extLst xmlns:a="http://schemas.openxmlformats.org/drawingml/2006/main">
+              <a:ext uri="{FF2B5EF4-FFF2-40B4-BE49-F238E27FC236}">
+                <a16:creationId xmlns:a16="http://schemas.microsoft.com/office/drawing/2014/main" id="{9B2C7AD6-7B7F-4A85-A2E5-E27CC0B8FF45}"/>
+              </a:ext>
+            </a:extLst>
+          </p:cNvPr>
+          <p:cNvSpPr>
+            <a:spLocks xmlns:a="http://schemas.openxmlformats.org/drawingml/2006/main" noGrp="1"/>
+          </p:cNvSpPr>
+          <p:nvPr/>
+        </p:nvSpPr>
+        <p:spPr>
+          <a:xfrm xmlns:a="http://schemas.openxmlformats.org/drawingml/2006/main">
+            <a:off x="6495585" y="3124200"/>
+            <a:ext cx="171450" cy="171450"/>
+          </a:xfrm>
+          <a:prstGeom xmlns:a="http://schemas.openxmlformats.org/drawingml/2006/main" prst="ellipse">
+            <a:avLst/>
+          </a:prstGeom>
+          <a:solidFill xmlns:a="http://schemas.openxmlformats.org/drawingml/2006/main">
+            <a:srgbClr val="FFD74B"/>
+          </a:solidFill>
+          <a:ln xmlns:a="http://schemas.openxmlformats.org/drawingml/2006/main" w="19050">
+            <a:solidFill>
+              <a:srgbClr val="102A2E"/>
+            </a:solidFill>
+            <a:prstDash val="solid"/>
+          </a:ln>
+        </p:spPr>
+      </p:sp>
+      <p:sp>
+        <p:nvSpPr>
+          <p:cNvPr id="26" name="">
+            <a:extLst xmlns:a="http://schemas.openxmlformats.org/drawingml/2006/main">
+              <a:ext uri="{FF2B5EF4-FFF2-40B4-BE49-F238E27FC236}">
+                <a16:creationId xmlns:a16="http://schemas.microsoft.com/office/drawing/2014/main" id="{9B67601D-11D6-4BD9-8F33-3EEE1899130F}"/>
+              </a:ext>
+            </a:extLst>
+          </p:cNvPr>
+          <p:cNvSpPr>
+            <a:spLocks xmlns:a="http://schemas.openxmlformats.org/drawingml/2006/main" noGrp="1"/>
+          </p:cNvSpPr>
+          <p:nvPr/>
+        </p:nvSpPr>
+        <p:spPr>
+          <a:xfrm xmlns:a="http://schemas.openxmlformats.org/drawingml/2006/main">
+            <a:off x="5828835" y="2038350"/>
+            <a:ext cx="1524000" cy="285750"/>
+          </a:xfrm>
+          <a:prstGeom xmlns:a="http://schemas.openxmlformats.org/drawingml/2006/main" prst="rect">
+            <a:avLst/>
+          </a:prstGeom>
+          <a:noFill xmlns:a="http://schemas.openxmlformats.org/drawingml/2006/main"/>
+          <a:ln xmlns:a="http://schemas.openxmlformats.org/drawingml/2006/main" w="0">
+            <a:noFill/>
+            <a:prstDash val="solid"/>
+          </a:ln>
+        </p:spPr>
+        <p:txBody>
+          <a:bodyPr xmlns:a="http://schemas.openxmlformats.org/drawingml/2006/main" anchor="ctr"/>
+          <a:lstStyle xmlns:a="http://schemas.openxmlformats.org/drawingml/2006/main"/>
+          <a:p xmlns:a="http://schemas.openxmlformats.org/drawingml/2006/main">
+            <a:pPr algn="ctr">
+              <a:defRPr sz="1125" b="1">
+                <a:solidFill>
+                  <a:srgbClr val="102A2E"/>
+                </a:solidFill>
+              </a:defRPr>
+            </a:pPr>
+            <a:r>
+              <a:rPr sz="1125" b="1">
+                <a:solidFill>
+                  <a:srgbClr val="102A2E"/>
+                </a:solidFill>
+              </a:rPr>
+              <a:t>Phantasmal Flames · 13d</a:t>
+            </a:r>
+          </a:p>
+        </p:txBody>
+      </p:sp>
+      <p:sp>
+        <p:nvSpPr>
+          <p:cNvPr id="27" name="">
+            <a:extLst xmlns:a="http://schemas.openxmlformats.org/drawingml/2006/main">
+              <a:ext uri="{FF2B5EF4-FFF2-40B4-BE49-F238E27FC236}">
+                <a16:creationId xmlns:a16="http://schemas.microsoft.com/office/drawing/2014/main" id="{D8F135FF-20B8-49C5-AC4F-64EB4F09B6ED}"/>
+              </a:ext>
+            </a:extLst>
+          </p:cNvPr>
+          <p:cNvSpPr>
+            <a:spLocks xmlns:a="http://schemas.openxmlformats.org/drawingml/2006/main" noGrp="1"/>
+          </p:cNvSpPr>
+          <p:nvPr/>
+        </p:nvSpPr>
+        <p:spPr>
+          <a:xfrm xmlns:a="http://schemas.openxmlformats.org/drawingml/2006/main">
+            <a:off x="6820829" y="3124200"/>
+            <a:ext cx="171450" cy="171450"/>
+          </a:xfrm>
+          <a:prstGeom xmlns:a="http://schemas.openxmlformats.org/drawingml/2006/main" prst="ellipse">
+            <a:avLst/>
+          </a:prstGeom>
+          <a:solidFill xmlns:a="http://schemas.openxmlformats.org/drawingml/2006/main">
+            <a:srgbClr val="ED5A53"/>
+          </a:solidFill>
+          <a:ln xmlns:a="http://schemas.openxmlformats.org/drawingml/2006/main" w="19050">
+            <a:solidFill>
+              <a:srgbClr val="102A2E"/>
+            </a:solidFill>
+            <a:prstDash val="solid"/>
+          </a:ln>
+        </p:spPr>
+      </p:sp>
+      <p:sp>
+        <p:nvSpPr>
+          <p:cNvPr id="28" name="">
+            <a:extLst xmlns:a="http://schemas.openxmlformats.org/drawingml/2006/main">
+              <a:ext uri="{FF2B5EF4-FFF2-40B4-BE49-F238E27FC236}">
+                <a16:creationId xmlns:a16="http://schemas.microsoft.com/office/drawing/2014/main" id="{38393C2A-7A23-4521-A2A3-E5CEC58DDFA9}"/>
+              </a:ext>
+            </a:extLst>
+          </p:cNvPr>
+          <p:cNvSpPr>
+            <a:spLocks xmlns:a="http://schemas.openxmlformats.org/drawingml/2006/main" noGrp="1"/>
+          </p:cNvSpPr>
+          <p:nvPr/>
+        </p:nvSpPr>
+        <p:spPr>
+          <a:xfrm xmlns:a="http://schemas.openxmlformats.org/drawingml/2006/main">
+            <a:off x="6154079" y="3943350"/>
+            <a:ext cx="1524000" cy="285750"/>
+          </a:xfrm>
+          <a:prstGeom xmlns:a="http://schemas.openxmlformats.org/drawingml/2006/main" prst="rect">
+            <a:avLst/>
+          </a:prstGeom>
+          <a:noFill xmlns:a="http://schemas.openxmlformats.org/drawingml/2006/main"/>
+          <a:ln xmlns:a="http://schemas.openxmlformats.org/drawingml/2006/main" w="0">
+            <a:noFill/>
+            <a:prstDash val="solid"/>
+          </a:ln>
+        </p:spPr>
+        <p:txBody>
+          <a:bodyPr xmlns:a="http://schemas.openxmlformats.org/drawingml/2006/main" anchor="ctr"/>
+          <a:lstStyle xmlns:a="http://schemas.openxmlformats.org/drawingml/2006/main"/>
+          <a:p xmlns:a="http://schemas.openxmlformats.org/drawingml/2006/main">
+            <a:pPr algn="ctr">
+              <a:defRPr sz="1125" b="1">
+                <a:solidFill>
+                  <a:srgbClr val="102A2E"/>
+                </a:solidFill>
+              </a:defRPr>
+            </a:pPr>
+            <a:r>
+              <a:rPr sz="1125" b="1">
+                <a:solidFill>
+                  <a:srgbClr val="102A2E"/>
+                </a:solidFill>
+              </a:rPr>
+              <a:t>30th Celebration · 15d</a:t>
+            </a:r>
+          </a:p>
+        </p:txBody>
+      </p:sp>
+      <p:sp>
+        <p:nvSpPr>
+          <p:cNvPr id="29" name="">
+            <a:extLst xmlns:a="http://schemas.openxmlformats.org/drawingml/2006/main">
+              <a:ext uri="{FF2B5EF4-FFF2-40B4-BE49-F238E27FC236}">
+                <a16:creationId xmlns:a16="http://schemas.microsoft.com/office/drawing/2014/main" id="{728B5BD9-3015-4C52-AA3E-B5D7B22920DA}"/>
+              </a:ext>
+            </a:extLst>
+          </p:cNvPr>
+          <p:cNvSpPr>
+            <a:spLocks xmlns:a="http://schemas.openxmlformats.org/drawingml/2006/main" noGrp="1"/>
+          </p:cNvSpPr>
+          <p:nvPr/>
+        </p:nvSpPr>
+        <p:spPr>
+          <a:xfrm xmlns:a="http://schemas.openxmlformats.org/drawingml/2006/main">
+            <a:off x="9585402" y="3124200"/>
+            <a:ext cx="171450" cy="171450"/>
+          </a:xfrm>
+          <a:prstGeom xmlns:a="http://schemas.openxmlformats.org/drawingml/2006/main" prst="ellipse">
+            <a:avLst/>
+          </a:prstGeom>
+          <a:solidFill xmlns:a="http://schemas.openxmlformats.org/drawingml/2006/main">
+            <a:srgbClr val="FFD74B"/>
+          </a:solidFill>
+          <a:ln xmlns:a="http://schemas.openxmlformats.org/drawingml/2006/main" w="19050">
+            <a:solidFill>
+              <a:srgbClr val="102A2E"/>
+            </a:solidFill>
+            <a:prstDash val="solid"/>
+          </a:ln>
+        </p:spPr>
+      </p:sp>
+      <p:sp>
+        <p:nvSpPr>
+          <p:cNvPr id="30" name="">
+            <a:extLst xmlns:a="http://schemas.openxmlformats.org/drawingml/2006/main">
+              <a:ext uri="{FF2B5EF4-FFF2-40B4-BE49-F238E27FC236}">
+                <a16:creationId xmlns:a16="http://schemas.microsoft.com/office/drawing/2014/main" id="{9EAEB98B-79E7-4076-91CF-398192C30A39}"/>
+              </a:ext>
+            </a:extLst>
+          </p:cNvPr>
+          <p:cNvSpPr>
+            <a:spLocks xmlns:a="http://schemas.openxmlformats.org/drawingml/2006/main" noGrp="1"/>
+          </p:cNvSpPr>
+          <p:nvPr/>
+        </p:nvSpPr>
+        <p:spPr>
+          <a:xfrm xmlns:a="http://schemas.openxmlformats.org/drawingml/2006/main">
+            <a:off x="8918652" y="2324100"/>
+            <a:ext cx="1524000" cy="285750"/>
+          </a:xfrm>
+          <a:prstGeom xmlns:a="http://schemas.openxmlformats.org/drawingml/2006/main" prst="rect">
+            <a:avLst/>
+          </a:prstGeom>
+          <a:noFill xmlns:a="http://schemas.openxmlformats.org/drawingml/2006/main"/>
+          <a:ln xmlns:a="http://schemas.openxmlformats.org/drawingml/2006/main" w="0">
+            <a:noFill/>
+            <a:prstDash val="solid"/>
+          </a:ln>
+        </p:spPr>
+        <p:txBody>
+          <a:bodyPr xmlns:a="http://schemas.openxmlformats.org/drawingml/2006/main" anchor="ctr"/>
+          <a:lstStyle xmlns:a="http://schemas.openxmlformats.org/drawingml/2006/main"/>
+          <a:p xmlns:a="http://schemas.openxmlformats.org/drawingml/2006/main">
+            <a:pPr algn="ctr">
+              <a:defRPr sz="1125" b="1">
+                <a:solidFill>
+                  <a:srgbClr val="102A2E"/>
+                </a:solidFill>
+              </a:defRPr>
+            </a:pPr>
+            <a:r>
+              <a:rPr sz="1125" b="1">
+                <a:solidFill>
+                  <a:srgbClr val="102A2E"/>
+                </a:solidFill>
+              </a:rPr>
+              <a:t>Chaos Rising · 32d</a:t>
+            </a:r>
+          </a:p>
+        </p:txBody>
+      </p:sp>
+      <p:sp>
+        <p:nvSpPr>
+          <p:cNvPr id="31" name="">
+            <a:extLst xmlns:a="http://schemas.openxmlformats.org/drawingml/2006/main">
+              <a:ext uri="{FF2B5EF4-FFF2-40B4-BE49-F238E27FC236}">
+                <a16:creationId xmlns:a16="http://schemas.microsoft.com/office/drawing/2014/main" id="{A3A247F9-8A49-4E26-BB63-1006BA12091F}"/>
+              </a:ext>
+            </a:extLst>
+          </p:cNvPr>
+          <p:cNvSpPr>
+            <a:spLocks xmlns:a="http://schemas.openxmlformats.org/drawingml/2006/main" noGrp="1"/>
+          </p:cNvSpPr>
+          <p:nvPr/>
+        </p:nvSpPr>
+        <p:spPr>
+          <a:xfrm xmlns:a="http://schemas.openxmlformats.org/drawingml/2006/main">
+            <a:off x="11049000" y="3124200"/>
+            <a:ext cx="171450" cy="171450"/>
+          </a:xfrm>
+          <a:prstGeom xmlns:a="http://schemas.openxmlformats.org/drawingml/2006/main" prst="ellipse">
+            <a:avLst/>
+          </a:prstGeom>
+          <a:solidFill xmlns:a="http://schemas.openxmlformats.org/drawingml/2006/main">
+            <a:srgbClr val="FFD74B"/>
+          </a:solidFill>
+          <a:ln xmlns:a="http://schemas.openxmlformats.org/drawingml/2006/main" w="19050">
+            <a:solidFill>
+              <a:srgbClr val="102A2E"/>
+            </a:solidFill>
+            <a:prstDash val="solid"/>
+          </a:ln>
+        </p:spPr>
+      </p:sp>
+      <p:sp>
+        <p:nvSpPr>
+          <p:cNvPr id="32" name="">
+            <a:extLst xmlns:a="http://schemas.openxmlformats.org/drawingml/2006/main">
+              <a:ext uri="{FF2B5EF4-FFF2-40B4-BE49-F238E27FC236}">
+                <a16:creationId xmlns:a16="http://schemas.microsoft.com/office/drawing/2014/main" id="{453084D1-280B-4398-AF8C-C17445440285}"/>
+              </a:ext>
+            </a:extLst>
+          </p:cNvPr>
+          <p:cNvSpPr>
+            <a:spLocks xmlns:a="http://schemas.openxmlformats.org/drawingml/2006/main" noGrp="1"/>
+          </p:cNvSpPr>
+          <p:nvPr/>
+        </p:nvSpPr>
+        <p:spPr>
+          <a:xfrm xmlns:a="http://schemas.openxmlformats.org/drawingml/2006/main">
+            <a:off x="10001250" y="3848100"/>
+            <a:ext cx="1524000" cy="285750"/>
+          </a:xfrm>
+          <a:prstGeom xmlns:a="http://schemas.openxmlformats.org/drawingml/2006/main" prst="rect">
+            <a:avLst/>
+          </a:prstGeom>
+          <a:noFill xmlns:a="http://schemas.openxmlformats.org/drawingml/2006/main"/>
+          <a:ln xmlns:a="http://schemas.openxmlformats.org/drawingml/2006/main" w="0">
+            <a:noFill/>
+            <a:prstDash val="solid"/>
+          </a:ln>
+        </p:spPr>
+        <p:txBody>
+          <a:bodyPr xmlns:a="http://schemas.openxmlformats.org/drawingml/2006/main" anchor="ctr"/>
+          <a:lstStyle xmlns:a="http://schemas.openxmlformats.org/drawingml/2006/main"/>
+          <a:p xmlns:a="http://schemas.openxmlformats.org/drawingml/2006/main">
+            <a:pPr algn="ctr">
+              <a:defRPr sz="1125" b="1">
+                <a:solidFill>
+                  <a:srgbClr val="102A2E"/>
+                </a:solidFill>
+              </a:defRPr>
+            </a:pPr>
+            <a:r>
+              <a:rPr sz="1125" b="1">
+                <a:solidFill>
+                  <a:srgbClr val="102A2E"/>
+                </a:solidFill>
+              </a:rPr>
+              <a:t>Pitch Black · 41d</a:t>
+            </a:r>
+          </a:p>
+        </p:txBody>
+      </p:sp>
+      <p:sp>
+        <p:nvSpPr>
+          <p:cNvPr id="33" name="">
+            <a:extLst xmlns:a="http://schemas.openxmlformats.org/drawingml/2006/main">
+              <a:ext uri="{FF2B5EF4-FFF2-40B4-BE49-F238E27FC236}">
+                <a16:creationId xmlns:a16="http://schemas.microsoft.com/office/drawing/2014/main" id="{DC2EF2F3-D358-4C73-AD8F-19308729B8D3}"/>
+              </a:ext>
+            </a:extLst>
+          </p:cNvPr>
+          <p:cNvSpPr>
+            <a:spLocks xmlns:a="http://schemas.openxmlformats.org/drawingml/2006/main" noGrp="1"/>
+          </p:cNvSpPr>
+          <p:nvPr/>
+        </p:nvSpPr>
+        <p:spPr>
+          <a:xfrm xmlns:a="http://schemas.openxmlformats.org/drawingml/2006/main">
+            <a:off x="4286250" y="3695700"/>
+            <a:ext cx="952500" cy="266700"/>
+          </a:xfrm>
+          <a:prstGeom xmlns:a="http://schemas.openxmlformats.org/drawingml/2006/main" prst="rect">
+            <a:avLst/>
+          </a:prstGeom>
+          <a:noFill xmlns:a="http://schemas.openxmlformats.org/drawingml/2006/main"/>
+          <a:ln xmlns:a="http://schemas.openxmlformats.org/drawingml/2006/main" w="0">
+            <a:noFill/>
+            <a:prstDash val="solid"/>
+          </a:ln>
+        </p:spPr>
+        <p:txBody>
+          <a:bodyPr xmlns:a="http://schemas.openxmlformats.org/drawingml/2006/main" anchor="ctr"/>
+          <a:lstStyle xmlns:a="http://schemas.openxmlformats.org/drawingml/2006/main"/>
+          <a:p xmlns:a="http://schemas.openxmlformats.org/drawingml/2006/main">
+            <a:pPr>
+              <a:defRPr sz="1275" b="1">
+                <a:solidFill>
+                  <a:srgbClr val="ED5A53"/>
+                </a:solidFill>
+              </a:defRPr>
+            </a:pPr>
+            <a:r>
+              <a:rPr sz="1275" b="1">
+                <a:solidFill>
+                  <a:srgbClr val="ED5A53"/>
+                </a:solidFill>
+              </a:rPr>
+              <a:t>Reveal</a:t>
+            </a:r>
+          </a:p>
+        </p:txBody>
+      </p:sp>
+      <p:sp>
+        <p:nvSpPr>
+          <p:cNvPr id="34" name="">
+            <a:extLst xmlns:a="http://schemas.openxmlformats.org/drawingml/2006/main">
+              <a:ext uri="{FF2B5EF4-FFF2-40B4-BE49-F238E27FC236}">
+                <a16:creationId xmlns:a16="http://schemas.microsoft.com/office/drawing/2014/main" id="{4A9EBA3C-DEDC-4F7B-A8AC-29924DA4850B}"/>
+              </a:ext>
+            </a:extLst>
+          </p:cNvPr>
+          <p:cNvSpPr>
+            <a:spLocks xmlns:a="http://schemas.openxmlformats.org/drawingml/2006/main" noGrp="1"/>
+          </p:cNvSpPr>
+          <p:nvPr/>
+        </p:nvSpPr>
+        <p:spPr>
+          <a:xfrm xmlns:a="http://schemas.openxmlformats.org/drawingml/2006/main">
+            <a:off x="9620250" y="3695700"/>
+            <a:ext cx="1714500" cy="266700"/>
+          </a:xfrm>
+          <a:prstGeom xmlns:a="http://schemas.openxmlformats.org/drawingml/2006/main" prst="rect">
+            <a:avLst/>
+          </a:prstGeom>
+          <a:noFill xmlns:a="http://schemas.openxmlformats.org/drawingml/2006/main"/>
+          <a:ln xmlns:a="http://schemas.openxmlformats.org/drawingml/2006/main" w="0">
+            <a:noFill/>
+            <a:prstDash val="solid"/>
+          </a:ln>
+        </p:spPr>
+        <p:txBody>
+          <a:bodyPr xmlns:a="http://schemas.openxmlformats.org/drawingml/2006/main" anchor="ctr"/>
+          <a:lstStyle xmlns:a="http://schemas.openxmlformats.org/drawingml/2006/main"/>
+          <a:p xmlns:a="http://schemas.openxmlformats.org/drawingml/2006/main">
+            <a:pPr algn="r">
+              <a:defRPr sz="1275" b="1">
+                <a:solidFill>
+                  <a:srgbClr val="ED5A53"/>
+                </a:solidFill>
+              </a:defRPr>
+            </a:pPr>
+            <a:r>
+              <a:rPr sz="1275" b="1">
+                <a:solidFill>
+                  <a:srgbClr val="ED5A53"/>
+                </a:solidFill>
+              </a:rPr>
+              <a:t>Pokémon Center live</a:t>
+            </a:r>
+          </a:p>
+        </p:txBody>
+      </p:sp>
+      <p:sp>
+        <p:nvSpPr>
+          <p:cNvPr id="35" name="">
+            <a:extLst xmlns:a="http://schemas.openxmlformats.org/drawingml/2006/main">
+              <a:ext uri="{FF2B5EF4-FFF2-40B4-BE49-F238E27FC236}">
+                <a16:creationId xmlns:a16="http://schemas.microsoft.com/office/drawing/2014/main" id="{BEE4A2DE-DBBD-4225-B689-313FF0F861F1}"/>
+              </a:ext>
+            </a:extLst>
+          </p:cNvPr>
+          <p:cNvSpPr>
+            <a:spLocks xmlns:a="http://schemas.openxmlformats.org/drawingml/2006/main" noGrp="1"/>
+          </p:cNvSpPr>
+          <p:nvPr/>
+        </p:nvSpPr>
+        <p:spPr>
+          <a:xfrm xmlns:a="http://schemas.openxmlformats.org/drawingml/2006/main">
+            <a:off x="0" y="6000750"/>
+            <a:ext cx="12192000" cy="857250"/>
+          </a:xfrm>
+          <a:prstGeom xmlns:a="http://schemas.openxmlformats.org/drawingml/2006/main" prst="rect">
+            <a:avLst/>
+          </a:prstGeom>
+          <a:solidFill xmlns:a="http://schemas.openxmlformats.org/drawingml/2006/main">
+            <a:srgbClr val="102A2E"/>
+          </a:solidFill>
+          <a:ln xmlns:a="http://schemas.openxmlformats.org/drawingml/2006/main" w="0">
+            <a:solidFill>
+              <a:srgbClr val="102A2E"/>
+            </a:solidFill>
+            <a:prstDash val="solid"/>
+          </a:ln>
+        </p:spPr>
+      </p:sp>
+      <p:sp>
+        <p:nvSpPr>
+          <p:cNvPr id="36" name="">
+            <a:extLst xmlns:a="http://schemas.openxmlformats.org/drawingml/2006/main">
+              <a:ext uri="{FF2B5EF4-FFF2-40B4-BE49-F238E27FC236}">
+                <a16:creationId xmlns:a16="http://schemas.microsoft.com/office/drawing/2014/main" id="{C93D0F46-9AF9-4FC6-868D-2F1AA86092A3}"/>
+              </a:ext>
+            </a:extLst>
+          </p:cNvPr>
+          <p:cNvSpPr>
+            <a:spLocks xmlns:a="http://schemas.openxmlformats.org/drawingml/2006/main" noGrp="1"/>
+          </p:cNvSpPr>
+          <p:nvPr/>
+        </p:nvSpPr>
+        <p:spPr>
+          <a:xfrm xmlns:a="http://schemas.openxmlformats.org/drawingml/2006/main">
+            <a:off x="495300" y="6229350"/>
+            <a:ext cx="323850" cy="323850"/>
+          </a:xfrm>
+          <a:prstGeom xmlns:a="http://schemas.openxmlformats.org/drawingml/2006/main" prst="ellipse">
+            <a:avLst/>
+          </a:prstGeom>
+          <a:solidFill xmlns:a="http://schemas.openxmlformats.org/drawingml/2006/main">
+            <a:srgbClr val="FFD74B"/>
+          </a:solidFill>
           <a:ln xmlns:a="http://schemas.openxmlformats.org/drawingml/2006/main" w="0">
             <a:solidFill>
               <a:srgbClr val="FFD74B"/>
@@ -6106,10 +7458,10 @@
       </p:sp>
       <p:sp>
         <p:nvSpPr>
-          <p:cNvPr id="6" name="">
-            <a:extLst xmlns:a="http://schemas.openxmlformats.org/drawingml/2006/main">
-              <a:ext uri="{FF2B5EF4-FFF2-40B4-BE49-F238E27FC236}">
-                <a16:creationId xmlns:a16="http://schemas.microsoft.com/office/drawing/2014/main" id="{143222F0-A547-4A65-A367-DE24C47C043C}"/>
+          <p:cNvPr id="37" name="">
+            <a:extLst xmlns:a="http://schemas.openxmlformats.org/drawingml/2006/main">
+              <a:ext uri="{FF2B5EF4-FFF2-40B4-BE49-F238E27FC236}">
+                <a16:creationId xmlns:a16="http://schemas.microsoft.com/office/drawing/2014/main" id="{FB0B48F8-A8BD-4744-A8BC-BA72B6BE2475}"/>
               </a:ext>
             </a:extLst>
           </p:cNvPr>
@@ -6149,7 +7501,7 @@
                   <a:srgbClr val="FFFFFF"/>
                 </a:solidFill>
               </a:rPr>
-              <a:t>First seen, price, official release, source, and last check stay visible.</a:t>
+              <a:t>Official confirmation is the start signal: watch immediately, then keep monitoring.</a:t>
             </a:r>
           </a:p>
         </p:txBody>
@@ -6157,7 +7509,7 @@
     </p:spTree>
     <p:extLst>
       <p:ext uri="{BB962C8B-B14F-4D97-AF65-F5344CB8AC3E}">
-        <p14:creationId xmlns:p14="http://schemas.microsoft.com/office/powerpoint/2010/main" val="1718621314"/>
+        <p14:creationId xmlns:p14="http://schemas.microsoft.com/office/powerpoint/2010/main" val="161077234"/>
       </p:ext>
     </p:extLst>
   </p:cSld>
@@ -6188,7 +7540,7 @@
           <p:cNvPr id="11" name="">
             <a:extLst xmlns:a="http://schemas.openxmlformats.org/drawingml/2006/main">
               <a:ext uri="{FF2B5EF4-FFF2-40B4-BE49-F238E27FC236}">
-                <a16:creationId xmlns:a16="http://schemas.microsoft.com/office/drawing/2014/main" id="{501766A9-BB86-489F-AF32-C793798F9FC8}"/>
+                <a16:creationId xmlns:a16="http://schemas.microsoft.com/office/drawing/2014/main" id="{8E4FD186-0D94-41F5-B065-75AA535C910E}"/>
               </a:ext>
             </a:extLst>
           </p:cNvPr>
@@ -6238,7 +7590,7 @@
           <p:cNvPr id="2" name="">
             <a:extLst xmlns:a="http://schemas.openxmlformats.org/drawingml/2006/main">
               <a:ext uri="{FF2B5EF4-FFF2-40B4-BE49-F238E27FC236}">
-                <a16:creationId xmlns:a16="http://schemas.microsoft.com/office/drawing/2014/main" id="{9BDBC382-8705-4675-8266-18267A441766}"/>
+                <a16:creationId xmlns:a16="http://schemas.microsoft.com/office/drawing/2014/main" id="{8C4E50F1-38AA-4420-8E55-CB39B84EDEDB}"/>
               </a:ext>
             </a:extLst>
           </p:cNvPr>
@@ -6292,7 +7644,7 @@
           <p:nvPr/>
         </p:nvPicPr>
         <p:blipFill>
-          <a:blip xmlns:r="http://schemas.openxmlformats.org/officeDocument/2006/relationships" xmlns:a="http://schemas.openxmlformats.org/drawingml/2006/main" r:embed="R52bfcd221e5e4b2c"/>
+          <a:blip xmlns:r="http://schemas.openxmlformats.org/officeDocument/2006/relationships" xmlns:a="http://schemas.openxmlformats.org/drawingml/2006/main" r:embed="R766a0c17b3cc45e6"/>
           <a:srcRect xmlns:a="http://schemas.openxmlformats.org/drawingml/2006/main" l="0" t="11431" r="0" b="11431"/>
           <a:stretch xmlns:a="http://schemas.openxmlformats.org/drawingml/2006/main">
             <a:fillRect l="0" t="0" r="0" b="0"/>
@@ -6315,7 +7667,7 @@
           <p:cNvPr id="4" name="">
             <a:extLst xmlns:a="http://schemas.openxmlformats.org/drawingml/2006/main">
               <a:ext uri="{FF2B5EF4-FFF2-40B4-BE49-F238E27FC236}">
-                <a16:creationId xmlns:a16="http://schemas.microsoft.com/office/drawing/2014/main" id="{946AE426-8308-43B2-930D-3D27E2CB80CD}"/>
+                <a16:creationId xmlns:a16="http://schemas.microsoft.com/office/drawing/2014/main" id="{C137F1B2-E018-4112-9DD4-5792FFC8E469}"/>
               </a:ext>
             </a:extLst>
           </p:cNvPr>
@@ -6365,7 +7717,7 @@
           <p:cNvPr id="5" name="">
             <a:extLst xmlns:a="http://schemas.openxmlformats.org/drawingml/2006/main">
               <a:ext uri="{FF2B5EF4-FFF2-40B4-BE49-F238E27FC236}">
-                <a16:creationId xmlns:a16="http://schemas.microsoft.com/office/drawing/2014/main" id="{A94B5408-8C9E-4896-8B1A-AC7B7FBBEFE4}"/>
+                <a16:creationId xmlns:a16="http://schemas.microsoft.com/office/drawing/2014/main" id="{3C83FB29-3E72-43DC-98EF-6E4C4E1D28DB}"/>
               </a:ext>
             </a:extLst>
           </p:cNvPr>
@@ -6415,7 +7767,7 @@
           <p:cNvPr id="6" name="">
             <a:extLst xmlns:a="http://schemas.openxmlformats.org/drawingml/2006/main">
               <a:ext uri="{FF2B5EF4-FFF2-40B4-BE49-F238E27FC236}">
-                <a16:creationId xmlns:a16="http://schemas.microsoft.com/office/drawing/2014/main" id="{68B3B121-3510-4B8C-A257-A79DB62E6DBC}"/>
+                <a16:creationId xmlns:a16="http://schemas.microsoft.com/office/drawing/2014/main" id="{AE5D9B76-F68A-45A3-B19A-ADBC59CFA1D0}"/>
               </a:ext>
             </a:extLst>
           </p:cNvPr>
@@ -6465,7 +7817,7 @@
           <p:cNvPr id="7" name="">
             <a:extLst xmlns:a="http://schemas.openxmlformats.org/drawingml/2006/main">
               <a:ext uri="{FF2B5EF4-FFF2-40B4-BE49-F238E27FC236}">
-                <a16:creationId xmlns:a16="http://schemas.microsoft.com/office/drawing/2014/main" id="{F3DA9098-D9B5-4614-94A4-58172E6718AF}"/>
+                <a16:creationId xmlns:a16="http://schemas.microsoft.com/office/drawing/2014/main" id="{F6FFB7EE-6112-4B4A-BA98-08CEEFF15023}"/>
               </a:ext>
             </a:extLst>
           </p:cNvPr>
@@ -6505,7 +7857,7 @@
                   <a:srgbClr val="102A2E"/>
                 </a:solidFill>
               </a:rPr>
-              <a:t>The opportunity was reported sold out, so the record moved out of Early-signal radar.</a:t>
+              <a:t>The opportunity was reported sold out, so it moved from the active radar into the Canadian availability record.</a:t>
             </a:r>
           </a:p>
         </p:txBody>
@@ -6515,7 +7867,7 @@
           <p:cNvPr id="8" name="">
             <a:extLst xmlns:a="http://schemas.openxmlformats.org/drawingml/2006/main">
               <a:ext uri="{FF2B5EF4-FFF2-40B4-BE49-F238E27FC236}">
-                <a16:creationId xmlns:a16="http://schemas.microsoft.com/office/drawing/2014/main" id="{A88783E9-36A5-43CA-8831-204929DC0319}"/>
+                <a16:creationId xmlns:a16="http://schemas.microsoft.com/office/drawing/2014/main" id="{15ECF979-CE06-4B4D-8ED3-11B99868BF91}"/>
               </a:ext>
             </a:extLst>
           </p:cNvPr>
@@ -6548,7 +7900,7 @@
           <p:cNvPr id="9" name="">
             <a:extLst xmlns:a="http://schemas.openxmlformats.org/drawingml/2006/main">
               <a:ext uri="{FF2B5EF4-FFF2-40B4-BE49-F238E27FC236}">
-                <a16:creationId xmlns:a16="http://schemas.microsoft.com/office/drawing/2014/main" id="{EEF90615-7BF2-4AAA-BFDD-E2814303E3FC}"/>
+                <a16:creationId xmlns:a16="http://schemas.microsoft.com/office/drawing/2014/main" id="{DED84933-87DC-4A12-9FD6-B7ECD6D0B6DE}"/>
               </a:ext>
             </a:extLst>
           </p:cNvPr>
@@ -6581,7 +7933,7 @@
           <p:cNvPr id="10" name="">
             <a:extLst xmlns:a="http://schemas.openxmlformats.org/drawingml/2006/main">
               <a:ext uri="{FF2B5EF4-FFF2-40B4-BE49-F238E27FC236}">
-                <a16:creationId xmlns:a16="http://schemas.microsoft.com/office/drawing/2014/main" id="{9E751572-591E-4B2D-AC8C-98A1906CC3AD}"/>
+                <a16:creationId xmlns:a16="http://schemas.microsoft.com/office/drawing/2014/main" id="{FFF5B754-5778-427A-89FA-225D29D10187}"/>
               </a:ext>
             </a:extLst>
           </p:cNvPr>
@@ -6629,7 +7981,7 @@
     </p:spTree>
     <p:extLst>
       <p:ext uri="{BB962C8B-B14F-4D97-AF65-F5344CB8AC3E}">
-        <p14:creationId xmlns:p14="http://schemas.microsoft.com/office/powerpoint/2010/main" val="620589791"/>
+        <p14:creationId xmlns:p14="http://schemas.microsoft.com/office/powerpoint/2010/main" val="435994438"/>
       </p:ext>
     </p:extLst>
   </p:cSld>
@@ -6660,7 +8012,7 @@
           <p:cNvPr id="18" name="">
             <a:extLst xmlns:a="http://schemas.openxmlformats.org/drawingml/2006/main">
               <a:ext uri="{FF2B5EF4-FFF2-40B4-BE49-F238E27FC236}">
-                <a16:creationId xmlns:a16="http://schemas.microsoft.com/office/drawing/2014/main" id="{43E694CB-28FD-4298-B7EF-F80754EA02E4}"/>
+                <a16:creationId xmlns:a16="http://schemas.microsoft.com/office/drawing/2014/main" id="{67D3BA80-8339-4E54-8B93-2F18B104B32A}"/>
               </a:ext>
             </a:extLst>
           </p:cNvPr>
@@ -6710,7 +8062,7 @@
           <p:cNvPr id="2" name="">
             <a:extLst xmlns:a="http://schemas.openxmlformats.org/drawingml/2006/main">
               <a:ext uri="{FF2B5EF4-FFF2-40B4-BE49-F238E27FC236}">
-                <a16:creationId xmlns:a16="http://schemas.microsoft.com/office/drawing/2014/main" id="{A5DCF69A-7F78-4459-BEB9-CBF623EF2B14}"/>
+                <a16:creationId xmlns:a16="http://schemas.microsoft.com/office/drawing/2014/main" id="{3809A728-3421-4D0D-BB12-AE2B7A7267DA}"/>
               </a:ext>
             </a:extLst>
           </p:cNvPr>
@@ -6760,7 +8112,7 @@
           <p:cNvPr id="3" name="">
             <a:extLst xmlns:a="http://schemas.openxmlformats.org/drawingml/2006/main">
               <a:ext uri="{FF2B5EF4-FFF2-40B4-BE49-F238E27FC236}">
-                <a16:creationId xmlns:a16="http://schemas.microsoft.com/office/drawing/2014/main" id="{40FEC0CF-C99A-4175-B6BC-128C503091E0}"/>
+                <a16:creationId xmlns:a16="http://schemas.microsoft.com/office/drawing/2014/main" id="{D14C67AE-10B7-4D17-9DF4-21FA997A8676}"/>
               </a:ext>
             </a:extLst>
           </p:cNvPr>
@@ -6793,7 +8145,7 @@
           <p:cNvPr id="4" name="">
             <a:extLst xmlns:a="http://schemas.openxmlformats.org/drawingml/2006/main">
               <a:ext uri="{FF2B5EF4-FFF2-40B4-BE49-F238E27FC236}">
-                <a16:creationId xmlns:a16="http://schemas.microsoft.com/office/drawing/2014/main" id="{A4C4E27E-26DB-47EF-9005-0F31E04D4EB3}"/>
+                <a16:creationId xmlns:a16="http://schemas.microsoft.com/office/drawing/2014/main" id="{D860E41D-F715-438B-B289-032131008CCE}"/>
               </a:ext>
             </a:extLst>
           </p:cNvPr>
@@ -6843,7 +8195,7 @@
           <p:cNvPr id="5" name="">
             <a:extLst xmlns:a="http://schemas.openxmlformats.org/drawingml/2006/main">
               <a:ext uri="{FF2B5EF4-FFF2-40B4-BE49-F238E27FC236}">
-                <a16:creationId xmlns:a16="http://schemas.microsoft.com/office/drawing/2014/main" id="{E194BE86-EEA3-4776-9162-0C33E7CDAFDC}"/>
+                <a16:creationId xmlns:a16="http://schemas.microsoft.com/office/drawing/2014/main" id="{F6F673D7-E3C3-4B5E-BD65-B13C96334618}"/>
               </a:ext>
             </a:extLst>
           </p:cNvPr>
@@ -6893,7 +8245,7 @@
           <p:cNvPr id="6" name="">
             <a:extLst xmlns:a="http://schemas.openxmlformats.org/drawingml/2006/main">
               <a:ext uri="{FF2B5EF4-FFF2-40B4-BE49-F238E27FC236}">
-                <a16:creationId xmlns:a16="http://schemas.microsoft.com/office/drawing/2014/main" id="{5F594A27-59C0-4164-90E2-6FA4C756E517}"/>
+                <a16:creationId xmlns:a16="http://schemas.microsoft.com/office/drawing/2014/main" id="{DDFBF26F-61C9-479B-8F3F-08419F730491}"/>
               </a:ext>
             </a:extLst>
           </p:cNvPr>
@@ -6943,7 +8295,7 @@
           <p:cNvPr id="7" name="">
             <a:extLst xmlns:a="http://schemas.openxmlformats.org/drawingml/2006/main">
               <a:ext uri="{FF2B5EF4-FFF2-40B4-BE49-F238E27FC236}">
-                <a16:creationId xmlns:a16="http://schemas.microsoft.com/office/drawing/2014/main" id="{A7A47321-4CBD-4826-9A35-262423C1176B}"/>
+                <a16:creationId xmlns:a16="http://schemas.microsoft.com/office/drawing/2014/main" id="{3CC57AF0-13CB-4169-9675-4536AF7E8165}"/>
               </a:ext>
             </a:extLst>
           </p:cNvPr>
@@ -6976,7 +8328,7 @@
           <p:cNvPr id="8" name="">
             <a:extLst xmlns:a="http://schemas.openxmlformats.org/drawingml/2006/main">
               <a:ext uri="{FF2B5EF4-FFF2-40B4-BE49-F238E27FC236}">
-                <a16:creationId xmlns:a16="http://schemas.microsoft.com/office/drawing/2014/main" id="{07EC4043-4B93-433E-8175-E69F2E15AB2C}"/>
+                <a16:creationId xmlns:a16="http://schemas.microsoft.com/office/drawing/2014/main" id="{6590167D-4A5D-4D9B-A64C-11C14B52A33D}"/>
               </a:ext>
             </a:extLst>
           </p:cNvPr>
@@ -7026,7 +8378,7 @@
           <p:cNvPr id="9" name="">
             <a:extLst xmlns:a="http://schemas.openxmlformats.org/drawingml/2006/main">
               <a:ext uri="{FF2B5EF4-FFF2-40B4-BE49-F238E27FC236}">
-                <a16:creationId xmlns:a16="http://schemas.microsoft.com/office/drawing/2014/main" id="{1589E720-7C84-4EB5-97D7-4F5FE1A6E5D4}"/>
+                <a16:creationId xmlns:a16="http://schemas.microsoft.com/office/drawing/2014/main" id="{8441EB10-1CF2-425D-93FC-9F9EAA4A3742}"/>
               </a:ext>
             </a:extLst>
           </p:cNvPr>
@@ -7076,7 +8428,7 @@
           <p:cNvPr id="10" name="">
             <a:extLst xmlns:a="http://schemas.openxmlformats.org/drawingml/2006/main">
               <a:ext uri="{FF2B5EF4-FFF2-40B4-BE49-F238E27FC236}">
-                <a16:creationId xmlns:a16="http://schemas.microsoft.com/office/drawing/2014/main" id="{0CF5B589-44E8-449F-9BD5-D6FBD792559B}"/>
+                <a16:creationId xmlns:a16="http://schemas.microsoft.com/office/drawing/2014/main" id="{F20E5E6C-45F1-4563-A911-56B519D157A3}"/>
               </a:ext>
             </a:extLst>
           </p:cNvPr>
@@ -7126,7 +8478,7 @@
           <p:cNvPr id="11" name="">
             <a:extLst xmlns:a="http://schemas.openxmlformats.org/drawingml/2006/main">
               <a:ext uri="{FF2B5EF4-FFF2-40B4-BE49-F238E27FC236}">
-                <a16:creationId xmlns:a16="http://schemas.microsoft.com/office/drawing/2014/main" id="{75B02629-0C5B-4E09-9024-E8D84AF8AAD5}"/>
+                <a16:creationId xmlns:a16="http://schemas.microsoft.com/office/drawing/2014/main" id="{89C500F0-B0B3-42DD-9ACD-DC760B3DE334}"/>
               </a:ext>
             </a:extLst>
           </p:cNvPr>
@@ -7159,7 +8511,7 @@
           <p:cNvPr id="12" name="">
             <a:extLst xmlns:a="http://schemas.openxmlformats.org/drawingml/2006/main">
               <a:ext uri="{FF2B5EF4-FFF2-40B4-BE49-F238E27FC236}">
-                <a16:creationId xmlns:a16="http://schemas.microsoft.com/office/drawing/2014/main" id="{5C8BCDC8-0EC0-4827-AB77-311E5851FBCC}"/>
+                <a16:creationId xmlns:a16="http://schemas.microsoft.com/office/drawing/2014/main" id="{CD395C18-87B0-48AA-A969-4BD82BEC4462}"/>
               </a:ext>
             </a:extLst>
           </p:cNvPr>
@@ -7209,7 +8561,7 @@
           <p:cNvPr id="13" name="">
             <a:extLst xmlns:a="http://schemas.openxmlformats.org/drawingml/2006/main">
               <a:ext uri="{FF2B5EF4-FFF2-40B4-BE49-F238E27FC236}">
-                <a16:creationId xmlns:a16="http://schemas.microsoft.com/office/drawing/2014/main" id="{C068E3F1-88B6-40B7-A3EF-3B665B158CDF}"/>
+                <a16:creationId xmlns:a16="http://schemas.microsoft.com/office/drawing/2014/main" id="{C271ACAC-FC4A-4CC6-B5FE-8B9728DDA48D}"/>
               </a:ext>
             </a:extLst>
           </p:cNvPr>
@@ -7259,7 +8611,7 @@
           <p:cNvPr id="14" name="">
             <a:extLst xmlns:a="http://schemas.openxmlformats.org/drawingml/2006/main">
               <a:ext uri="{FF2B5EF4-FFF2-40B4-BE49-F238E27FC236}">
-                <a16:creationId xmlns:a16="http://schemas.microsoft.com/office/drawing/2014/main" id="{C5F1B16D-AD4B-46E2-A778-93C33CC74B53}"/>
+                <a16:creationId xmlns:a16="http://schemas.microsoft.com/office/drawing/2014/main" id="{2207789C-C15C-4ABE-B83E-0A5FB706F49E}"/>
               </a:ext>
             </a:extLst>
           </p:cNvPr>
@@ -7309,7 +8661,7 @@
           <p:cNvPr id="15" name="">
             <a:extLst xmlns:a="http://schemas.openxmlformats.org/drawingml/2006/main">
               <a:ext uri="{FF2B5EF4-FFF2-40B4-BE49-F238E27FC236}">
-                <a16:creationId xmlns:a16="http://schemas.microsoft.com/office/drawing/2014/main" id="{90FDC375-CA0C-4D70-B9EF-B936D669EBE4}"/>
+                <a16:creationId xmlns:a16="http://schemas.microsoft.com/office/drawing/2014/main" id="{B3ECAE35-9E8E-47BC-9B20-09099082E361}"/>
               </a:ext>
             </a:extLst>
           </p:cNvPr>
@@ -7359,7 +8711,7 @@
           <p:cNvPr id="16" name="">
             <a:extLst xmlns:a="http://schemas.openxmlformats.org/drawingml/2006/main">
               <a:ext uri="{FF2B5EF4-FFF2-40B4-BE49-F238E27FC236}">
-                <a16:creationId xmlns:a16="http://schemas.microsoft.com/office/drawing/2014/main" id="{7D1A1CBF-253D-4F40-AFC3-6668F34C2A75}"/>
+                <a16:creationId xmlns:a16="http://schemas.microsoft.com/office/drawing/2014/main" id="{FCCF1341-6068-4352-A983-51F4D1C63675}"/>
               </a:ext>
             </a:extLst>
           </p:cNvPr>
@@ -7392,7 +8744,7 @@
           <p:cNvPr id="17" name="">
             <a:extLst xmlns:a="http://schemas.openxmlformats.org/drawingml/2006/main">
               <a:ext uri="{FF2B5EF4-FFF2-40B4-BE49-F238E27FC236}">
-                <a16:creationId xmlns:a16="http://schemas.microsoft.com/office/drawing/2014/main" id="{EA10EC1D-C9FE-4838-A85A-22892AECE916}"/>
+                <a16:creationId xmlns:a16="http://schemas.microsoft.com/office/drawing/2014/main" id="{808170A6-181C-4D16-937D-BF78317C3D06}"/>
               </a:ext>
             </a:extLst>
           </p:cNvPr>
@@ -7440,7 +8792,7 @@
     </p:spTree>
     <p:extLst>
       <p:ext uri="{BB962C8B-B14F-4D97-AF65-F5344CB8AC3E}">
-        <p14:creationId xmlns:p14="http://schemas.microsoft.com/office/powerpoint/2010/main" val="878208493"/>
+        <p14:creationId xmlns:p14="http://schemas.microsoft.com/office/powerpoint/2010/main" val="355683850"/>
       </p:ext>
     </p:extLst>
   </p:cSld>

</xml_diff>